<commit_message>
feat: SHAP 예측 설명 추가 + Streamlit Cloud 버그 수정
- src/femto_shap.py: 로컬 CPU SHAP 분석 스크립트 추가
  LinearExplainer(분류) + KernelExplainer(GRU, 시간축 평균 근사)
- 산출물/_imgs/S1~S3: SHAP beeswarm + 피처 중요도 비교 차트 3종
- 딥러닝_FEMTO_RUL_발표자료.pptx: 부록C SHAP 슬라이드 3장 추가
- 딥러닝_산출물_발표용.docx: 부록E SHAP 분석 섹션 추가
- data/FEMTO_processed/vif_results.csv: 실제 VIF 값 재계산
- src/femto_preprocess.py: temp_mean 전체 NaN 시 0 대체 처리
- app/streamlit_femto.py: df.empty 시 경고 메시지 개선
- models/femto_lstm_rul.keras: Cloud 배포용 LSTM 모델 추가
</commit_message>
<xml_diff>
--- a/Homework/DL_FactoryAutomation/산출물/딥러닝_FEMTO_RUL_발표자료.pptx
+++ b/Homework/DL_FactoryAutomation/산출물/딥러닝_FEMTO_RUL_발표자료.pptx
@@ -19,6 +19,11 @@
     <p:sldId id="267" r:id="rId18"/>
     <p:sldId id="268" r:id="rId19"/>
     <p:sldId id="269" r:id="rId20"/>
+    <p:sldId id="270" r:id="rId21"/>
+    <p:sldId id="271" r:id="rId22"/>
+    <p:sldId id="272" r:id="rId23"/>
+    <p:sldId id="273" r:id="rId24"/>
+    <p:sldId id="274" r:id="rId25"/>
   </p:sldIdLst>
   <p:sldSz cx="12188952" cy="6858000" type="screen4x3"/>
   <p:notesSz cx="6858000" cy="9144000"/>
@@ -5423,8 +5428,157 @@
         </p:nvSpPr>
         <p:spPr>
           <a:xfrm>
-            <a:off x="365760" y="1097280"/>
-            <a:ext cx="2212848" cy="548640"/>
+            <a:off x="274320" y="1024128"/>
+            <a:ext cx="2560320" cy="3840480"/>
+          </a:xfrm>
+          <a:prstGeom prst="rect">
+            <a:avLst/>
+          </a:prstGeom>
+          <a:solidFill>
+            <a:srgbClr val="D6E4F7"/>
+          </a:solidFill>
+          <a:ln>
+            <a:noFill/>
+          </a:ln>
+        </p:spPr>
+        <p:style>
+          <a:lnRef idx="1">
+            <a:schemeClr val="accent1"/>
+          </a:lnRef>
+          <a:fillRef idx="3">
+            <a:schemeClr val="accent1"/>
+          </a:fillRef>
+          <a:effectRef idx="2">
+            <a:schemeClr val="accent1"/>
+          </a:effectRef>
+          <a:fontRef idx="minor">
+            <a:schemeClr val="lt1"/>
+          </a:fontRef>
+        </p:style>
+        <p:txBody>
+          <a:bodyPr rtlCol="0" anchor="ctr"/>
+          <a:lstStyle/>
+          <a:p>
+            <a:pPr algn="ctr"/>
+          </a:p>
+        </p:txBody>
+      </p:sp>
+      <p:sp>
+        <p:nvSpPr>
+          <p:cNvPr id="7" name="TextBox 6"/>
+          <p:cNvSpPr txBox="1"/>
+          <p:nvPr/>
+        </p:nvSpPr>
+        <p:spPr>
+          <a:xfrm>
+            <a:off x="365760" y="1051560"/>
+            <a:ext cx="2377440" cy="365760"/>
+          </a:xfrm>
+          <a:prstGeom prst="rect">
+            <a:avLst/>
+          </a:prstGeom>
+          <a:noFill/>
+        </p:spPr>
+        <p:txBody>
+          <a:bodyPr wrap="square">
+            <a:spAutoFit/>
+          </a:bodyPr>
+          <a:lstStyle/>
+          <a:p>
+            <a:pPr algn="l"/>
+            <a:r>
+              <a:rPr sz="1200" b="1" i="0">
+                <a:solidFill>
+                  <a:srgbClr val="1F4E79"/>
+                </a:solidFill>
+                <a:latin typeface="맑은 고딕"/>
+              </a:rPr>
+              <a:t>⚙️ 사이드바</a:t>
+            </a:r>
+          </a:p>
+        </p:txBody>
+      </p:sp>
+      <p:sp>
+        <p:nvSpPr>
+          <p:cNvPr id="8" name="TextBox 7"/>
+          <p:cNvSpPr txBox="1"/>
+          <p:nvPr/>
+        </p:nvSpPr>
+        <p:spPr>
+          <a:xfrm>
+            <a:off x="320040" y="1463040"/>
+            <a:ext cx="2468880" cy="2560320"/>
+          </a:xfrm>
+          <a:prstGeom prst="rect">
+            <a:avLst/>
+          </a:prstGeom>
+          <a:noFill/>
+        </p:spPr>
+        <p:txBody>
+          <a:bodyPr wrap="square">
+            <a:spAutoFit/>
+          </a:bodyPr>
+          <a:lstStyle/>
+          <a:p>
+            <a:pPr algn="l"/>
+            <a:r>
+              <a:rPr sz="1100">
+                <a:solidFill>
+                  <a:srgbClr val="1A1A1A"/>
+                </a:solidFill>
+                <a:latin typeface="맑은 고딕"/>
+              </a:rPr>
+              <a:t>• ML 임계값 슬라이더 (기본 0.50)</a:t>
+            </a:r>
+          </a:p>
+          <a:p>
+            <a:pPr algn="l"/>
+            <a:r>
+              <a:rPr sz="1100">
+                <a:solidFill>
+                  <a:srgbClr val="1A1A1A"/>
+                </a:solidFill>
+                <a:latin typeface="맑은 고딕"/>
+              </a:rPr>
+              <a:t>• RUL 경보 기준 (기본 60분)</a:t>
+            </a:r>
+          </a:p>
+          <a:p>
+            <a:pPr algn="l"/>
+            <a:r>
+              <a:rPr sz="1100">
+                <a:solidFill>
+                  <a:srgbClr val="1A1A1A"/>
+                </a:solidFill>
+                <a:latin typeface="맑은 고딕"/>
+              </a:rPr>
+              <a:t>• 변경 이력 expander</a:t>
+            </a:r>
+          </a:p>
+          <a:p>
+            <a:pPr algn="l"/>
+            <a:r>
+              <a:rPr sz="1100">
+                <a:solidFill>
+                  <a:srgbClr val="1A1A1A"/>
+                </a:solidFill>
+                <a:latin typeface="맑은 고딕"/>
+              </a:rPr>
+              <a:t>• 실행 순서 안내</a:t>
+            </a:r>
+          </a:p>
+        </p:txBody>
+      </p:sp>
+      <p:sp>
+        <p:nvSpPr>
+          <p:cNvPr id="9" name="Rectangle 8"/>
+          <p:cNvSpPr/>
+          <p:nvPr/>
+        </p:nvSpPr>
+        <p:spPr>
+          <a:xfrm>
+            <a:off x="3017520" y="1024128"/>
+            <a:ext cx="1737360" cy="640080"/>
           </a:xfrm>
           <a:prstGeom prst="rect">
             <a:avLst/>
@@ -5460,14 +5614,14 @@
       </p:sp>
       <p:sp>
         <p:nvSpPr>
-          <p:cNvPr id="7" name="TextBox 6"/>
+          <p:cNvPr id="10" name="TextBox 9"/>
           <p:cNvSpPr txBox="1"/>
           <p:nvPr/>
         </p:nvSpPr>
         <p:spPr>
           <a:xfrm>
-            <a:off x="411480" y="1115568"/>
-            <a:ext cx="2103120" cy="502920"/>
+            <a:off x="3063240" y="1042415"/>
+            <a:ext cx="1645920" cy="594360"/>
           </a:xfrm>
           <a:prstGeom prst="rect">
             <a:avLst/>
@@ -5482,27 +5636,28 @@
           <a:p>
             <a:pPr algn="ctr"/>
             <a:r>
-              <a:rPr sz="1200" b="1" i="0">
+              <a:rPr sz="1100" b="1" i="0">
                 <a:solidFill>
                   <a:srgbClr val="FFFFFF"/>
                 </a:solidFill>
                 <a:latin typeface="맑은 고딕"/>
               </a:rPr>
-              <a:t>탭 1: 데이터 탐색</a:t>
-            </a:r>
-          </a:p>
-        </p:txBody>
-      </p:sp>
-      <p:sp>
-        <p:nvSpPr>
-          <p:cNvPr id="8" name="Rectangle 7"/>
+              <a:t>📊 탭 1
+데이터 탐색</a:t>
+            </a:r>
+          </a:p>
+        </p:txBody>
+      </p:sp>
+      <p:sp>
+        <p:nvSpPr>
+          <p:cNvPr id="11" name="Rectangle 10"/>
           <p:cNvSpPr/>
           <p:nvPr/>
         </p:nvSpPr>
         <p:spPr>
           <a:xfrm>
-            <a:off x="365760" y="1691640"/>
-            <a:ext cx="2212848" cy="2103120"/>
+            <a:off x="3017520" y="1691640"/>
+            <a:ext cx="1737360" cy="2697480"/>
           </a:xfrm>
           <a:prstGeom prst="rect">
             <a:avLst/>
@@ -5538,14 +5693,14 @@
       </p:sp>
       <p:sp>
         <p:nvSpPr>
-          <p:cNvPr id="9" name="TextBox 8"/>
+          <p:cNvPr id="12" name="TextBox 11"/>
           <p:cNvSpPr txBox="1"/>
           <p:nvPr/>
         </p:nvSpPr>
         <p:spPr>
           <a:xfrm>
-            <a:off x="457200" y="1783080"/>
-            <a:ext cx="2011680" cy="1920240"/>
+            <a:off x="3090672" y="1755648"/>
+            <a:ext cx="1600200" cy="2578608"/>
           </a:xfrm>
           <a:prstGeom prst="rect">
             <a:avLst/>
@@ -5560,29 +5715,30 @@
           <a:p>
             <a:pPr algn="l"/>
             <a:r>
-              <a:rPr sz="1200" b="0" i="0">
+              <a:rPr sz="1000" b="0" i="0">
                 <a:solidFill>
                   <a:srgbClr val="1A1A1A"/>
                 </a:solidFill>
                 <a:latin typeface="맑은 고딕"/>
               </a:rPr>
-              <a:t>RUL 곡선
-피처 트렌드
-VIF 분석</a:t>
-            </a:r>
-          </a:p>
-        </p:txBody>
-      </p:sp>
-      <p:sp>
-        <p:nvSpPr>
-          <p:cNvPr id="10" name="Rectangle 9"/>
+              <a:t>h_rms 추이
+열화 라벨 분포
+피처 박스플롯
+4개 KPI 메트릭</a:t>
+            </a:r>
+          </a:p>
+        </p:txBody>
+      </p:sp>
+      <p:sp>
+        <p:nvSpPr>
+          <p:cNvPr id="13" name="Rectangle 12"/>
           <p:cNvSpPr/>
           <p:nvPr/>
         </p:nvSpPr>
         <p:spPr>
           <a:xfrm>
-            <a:off x="2697479" y="1097280"/>
-            <a:ext cx="2212848" cy="548640"/>
+            <a:off x="4846320" y="1024128"/>
+            <a:ext cx="1737360" cy="640080"/>
           </a:xfrm>
           <a:prstGeom prst="rect">
             <a:avLst/>
@@ -5618,14 +5774,14 @@
       </p:sp>
       <p:sp>
         <p:nvSpPr>
-          <p:cNvPr id="11" name="TextBox 10"/>
+          <p:cNvPr id="14" name="TextBox 13"/>
           <p:cNvSpPr txBox="1"/>
           <p:nvPr/>
         </p:nvSpPr>
         <p:spPr>
           <a:xfrm>
-            <a:off x="2743199" y="1115568"/>
-            <a:ext cx="2103120" cy="502920"/>
+            <a:off x="4892040" y="1042415"/>
+            <a:ext cx="1645920" cy="594360"/>
           </a:xfrm>
           <a:prstGeom prst="rect">
             <a:avLst/>
@@ -5640,27 +5796,28 @@
           <a:p>
             <a:pPr algn="ctr"/>
             <a:r>
-              <a:rPr sz="1200" b="1" i="0">
+              <a:rPr sz="1100" b="1" i="0">
                 <a:solidFill>
                   <a:srgbClr val="FFFFFF"/>
                 </a:solidFill>
                 <a:latin typeface="맑은 고딕"/>
               </a:rPr>
-              <a:t>탭 2: ML 성능</a:t>
-            </a:r>
-          </a:p>
-        </p:txBody>
-      </p:sp>
-      <p:sp>
-        <p:nvSpPr>
-          <p:cNvPr id="12" name="Rectangle 11"/>
+              <a:t>🤖 탭 2
+ML 성능</a:t>
+            </a:r>
+          </a:p>
+        </p:txBody>
+      </p:sp>
+      <p:sp>
+        <p:nvSpPr>
+          <p:cNvPr id="15" name="Rectangle 14"/>
           <p:cNvSpPr/>
           <p:nvPr/>
         </p:nvSpPr>
         <p:spPr>
           <a:xfrm>
-            <a:off x="2697479" y="1691640"/>
-            <a:ext cx="2212848" cy="2103120"/>
+            <a:off x="4846320" y="1691640"/>
+            <a:ext cx="1737360" cy="2697480"/>
           </a:xfrm>
           <a:prstGeom prst="rect">
             <a:avLst/>
@@ -5696,14 +5853,14 @@
       </p:sp>
       <p:sp>
         <p:nvSpPr>
-          <p:cNvPr id="13" name="TextBox 12"/>
+          <p:cNvPr id="16" name="TextBox 15"/>
           <p:cNvSpPr txBox="1"/>
           <p:nvPr/>
         </p:nvSpPr>
         <p:spPr>
           <a:xfrm>
-            <a:off x="2788919" y="1783080"/>
-            <a:ext cx="2011680" cy="1920240"/>
+            <a:off x="4919472" y="1755648"/>
+            <a:ext cx="1600200" cy="2578608"/>
           </a:xfrm>
           <a:prstGeom prst="rect">
             <a:avLst/>
@@ -5718,28 +5875,30 @@
           <a:p>
             <a:pPr algn="l"/>
             <a:r>
-              <a:rPr sz="1200" b="0" i="0">
+              <a:rPr sz="1000" b="0" i="0">
                 <a:solidFill>
                   <a:srgbClr val="1A1A1A"/>
                 </a:solidFill>
                 <a:latin typeface="맑은 고딕"/>
               </a:rPr>
-              <a:t>RF 예측 결과
-피처 중요도</a:t>
-            </a:r>
-          </a:p>
-        </p:txBody>
-      </p:sp>
-      <p:sp>
-        <p:nvSpPr>
-          <p:cNvPr id="14" name="Rectangle 13"/>
+              <a:t>VIF 분석 표
+모델 3종 비교
+Feature Importance
+Confusion Matrix</a:t>
+            </a:r>
+          </a:p>
+        </p:txBody>
+      </p:sp>
+      <p:sp>
+        <p:nvSpPr>
+          <p:cNvPr id="17" name="Rectangle 16"/>
           <p:cNvSpPr/>
           <p:nvPr/>
         </p:nvSpPr>
         <p:spPr>
           <a:xfrm>
-            <a:off x="5029200" y="1097280"/>
-            <a:ext cx="2212848" cy="548640"/>
+            <a:off x="6675120" y="1024128"/>
+            <a:ext cx="1737360" cy="640080"/>
           </a:xfrm>
           <a:prstGeom prst="rect">
             <a:avLst/>
@@ -5775,14 +5934,14 @@
       </p:sp>
       <p:sp>
         <p:nvSpPr>
-          <p:cNvPr id="15" name="TextBox 14"/>
+          <p:cNvPr id="18" name="TextBox 17"/>
           <p:cNvSpPr txBox="1"/>
           <p:nvPr/>
         </p:nvSpPr>
         <p:spPr>
           <a:xfrm>
-            <a:off x="5074920" y="1115568"/>
-            <a:ext cx="2103120" cy="502920"/>
+            <a:off x="6720840" y="1042415"/>
+            <a:ext cx="1645920" cy="594360"/>
           </a:xfrm>
           <a:prstGeom prst="rect">
             <a:avLst/>
@@ -5797,27 +5956,28 @@
           <a:p>
             <a:pPr algn="ctr"/>
             <a:r>
-              <a:rPr sz="1200" b="1" i="0">
+              <a:rPr sz="1100" b="1" i="0">
                 <a:solidFill>
                   <a:srgbClr val="FFFFFF"/>
                 </a:solidFill>
                 <a:latin typeface="맑은 고딕"/>
               </a:rPr>
-              <a:t>탭 3: DL RUL 예측</a:t>
-            </a:r>
-          </a:p>
-        </p:txBody>
-      </p:sp>
-      <p:sp>
-        <p:nvSpPr>
-          <p:cNvPr id="16" name="Rectangle 15"/>
+              <a:t>🔮 탭 3
+DL RUL 예측</a:t>
+            </a:r>
+          </a:p>
+        </p:txBody>
+      </p:sp>
+      <p:sp>
+        <p:nvSpPr>
+          <p:cNvPr id="19" name="Rectangle 18"/>
           <p:cNvSpPr/>
           <p:nvPr/>
         </p:nvSpPr>
         <p:spPr>
           <a:xfrm>
-            <a:off x="5029200" y="1691640"/>
-            <a:ext cx="2212848" cy="2103120"/>
+            <a:off x="6675120" y="1691640"/>
+            <a:ext cx="1737360" cy="2697480"/>
           </a:xfrm>
           <a:prstGeom prst="rect">
             <a:avLst/>
@@ -5853,14 +6013,14 @@
       </p:sp>
       <p:sp>
         <p:nvSpPr>
-          <p:cNvPr id="17" name="TextBox 16"/>
+          <p:cNvPr id="20" name="TextBox 19"/>
           <p:cNvSpPr txBox="1"/>
           <p:nvPr/>
         </p:nvSpPr>
         <p:spPr>
           <a:xfrm>
-            <a:off x="5120640" y="1783080"/>
-            <a:ext cx="2011680" cy="1920240"/>
+            <a:off x="6748272" y="1755648"/>
+            <a:ext cx="1600200" cy="2578608"/>
           </a:xfrm>
           <a:prstGeom prst="rect">
             <a:avLst/>
@@ -5875,28 +6035,29 @@
           <a:p>
             <a:pPr algn="l"/>
             <a:r>
-              <a:rPr sz="1200" b="0" i="0">
+              <a:rPr sz="1000" b="0" i="0">
                 <a:solidFill>
                   <a:srgbClr val="1A1A1A"/>
                 </a:solidFill>
                 <a:latin typeface="맑은 고딕"/>
               </a:rPr>
-              <a:t>GRU v2 실시간
-RUL 경보 등급</a:t>
-            </a:r>
-          </a:p>
-        </p:txBody>
-      </p:sp>
-      <p:sp>
-        <p:nvSpPr>
-          <p:cNvPr id="18" name="Rectangle 17"/>
+              <a:t>ML vs LSTM 비교
+LSTM 학습곡선
+베어링 RUL 추이</a:t>
+            </a:r>
+          </a:p>
+        </p:txBody>
+      </p:sp>
+      <p:sp>
+        <p:nvSpPr>
+          <p:cNvPr id="21" name="Rectangle 20"/>
           <p:cNvSpPr/>
           <p:nvPr/>
         </p:nvSpPr>
         <p:spPr>
           <a:xfrm>
-            <a:off x="7360919" y="1097280"/>
-            <a:ext cx="2212848" cy="548640"/>
+            <a:off x="8503920" y="1024128"/>
+            <a:ext cx="1737360" cy="640080"/>
           </a:xfrm>
           <a:prstGeom prst="rect">
             <a:avLst/>
@@ -5932,14 +6093,14 @@
       </p:sp>
       <p:sp>
         <p:nvSpPr>
-          <p:cNvPr id="19" name="TextBox 18"/>
+          <p:cNvPr id="22" name="TextBox 21"/>
           <p:cNvSpPr txBox="1"/>
           <p:nvPr/>
         </p:nvSpPr>
         <p:spPr>
           <a:xfrm>
-            <a:off x="7406639" y="1115568"/>
-            <a:ext cx="2103120" cy="502920"/>
+            <a:off x="8549640" y="1042415"/>
+            <a:ext cx="1645920" cy="594360"/>
           </a:xfrm>
           <a:prstGeom prst="rect">
             <a:avLst/>
@@ -5954,27 +6115,28 @@
           <a:p>
             <a:pPr algn="ctr"/>
             <a:r>
-              <a:rPr sz="1200" b="1" i="0">
+              <a:rPr sz="1100" b="1" i="0">
                 <a:solidFill>
                   <a:srgbClr val="FFFFFF"/>
                 </a:solidFill>
                 <a:latin typeface="맑은 고딕"/>
               </a:rPr>
-              <a:t>탭 4: 통합 진단</a:t>
-            </a:r>
-          </a:p>
-        </p:txBody>
-      </p:sp>
-      <p:sp>
-        <p:nvSpPr>
-          <p:cNvPr id="20" name="Rectangle 19"/>
+              <a:t>🏭 탭 4
+통합 진단</a:t>
+            </a:r>
+          </a:p>
+        </p:txBody>
+      </p:sp>
+      <p:sp>
+        <p:nvSpPr>
+          <p:cNvPr id="23" name="Rectangle 22"/>
           <p:cNvSpPr/>
           <p:nvPr/>
         </p:nvSpPr>
         <p:spPr>
           <a:xfrm>
-            <a:off x="7360919" y="1691640"/>
-            <a:ext cx="2212848" cy="2103120"/>
+            <a:off x="8503920" y="1691640"/>
+            <a:ext cx="1737360" cy="2697480"/>
           </a:xfrm>
           <a:prstGeom prst="rect">
             <a:avLst/>
@@ -6010,14 +6172,14 @@
       </p:sp>
       <p:sp>
         <p:nvSpPr>
-          <p:cNvPr id="21" name="TextBox 20"/>
+          <p:cNvPr id="24" name="TextBox 23"/>
           <p:cNvSpPr txBox="1"/>
           <p:nvPr/>
         </p:nvSpPr>
         <p:spPr>
           <a:xfrm>
-            <a:off x="7452359" y="1783080"/>
-            <a:ext cx="2011680" cy="1920240"/>
+            <a:off x="8577072" y="1755648"/>
+            <a:ext cx="1600200" cy="2578608"/>
           </a:xfrm>
           <a:prstGeom prst="rect">
             <a:avLst/>
@@ -6032,28 +6194,30 @@
           <a:p>
             <a:pPr algn="l"/>
             <a:r>
-              <a:rPr sz="1200" b="0" i="0">
+              <a:rPr sz="1000" b="0" i="0">
                 <a:solidFill>
                   <a:srgbClr val="1A1A1A"/>
                 </a:solidFill>
                 <a:latin typeface="맑은 고딕"/>
               </a:rPr>
-              <a:t>ML+DL 융합
-임계값 조정</a:t>
-            </a:r>
-          </a:p>
-        </p:txBody>
-      </p:sp>
-      <p:sp>
-        <p:nvSpPr>
-          <p:cNvPr id="22" name="Rectangle 21"/>
+              <a:t>진동값 9개 슬라이더
+진단하기 버튼
+ML 열화 판정
+RUL &amp; 경보 등급</a:t>
+            </a:r>
+          </a:p>
+        </p:txBody>
+      </p:sp>
+      <p:sp>
+        <p:nvSpPr>
+          <p:cNvPr id="25" name="Rectangle 24"/>
           <p:cNvSpPr/>
           <p:nvPr/>
         </p:nvSpPr>
         <p:spPr>
           <a:xfrm>
-            <a:off x="9692640" y="1097280"/>
-            <a:ext cx="2212848" cy="548640"/>
+            <a:off x="10332720" y="1024128"/>
+            <a:ext cx="1737360" cy="640080"/>
           </a:xfrm>
           <a:prstGeom prst="rect">
             <a:avLst/>
@@ -6089,14 +6253,14 @@
       </p:sp>
       <p:sp>
         <p:nvSpPr>
-          <p:cNvPr id="23" name="TextBox 22"/>
+          <p:cNvPr id="26" name="TextBox 25"/>
           <p:cNvSpPr txBox="1"/>
           <p:nvPr/>
         </p:nvSpPr>
         <p:spPr>
           <a:xfrm>
-            <a:off x="9738360" y="1115568"/>
-            <a:ext cx="2103120" cy="502920"/>
+            <a:off x="10378440" y="1042415"/>
+            <a:ext cx="1645920" cy="594360"/>
           </a:xfrm>
           <a:prstGeom prst="rect">
             <a:avLst/>
@@ -6111,27 +6275,28 @@
           <a:p>
             <a:pPr algn="ctr"/>
             <a:r>
-              <a:rPr sz="1200" b="1" i="0">
+              <a:rPr sz="1100" b="1" i="0">
                 <a:solidFill>
                   <a:srgbClr val="FFFFFF"/>
                 </a:solidFill>
                 <a:latin typeface="맑은 고딕"/>
               </a:rPr>
-              <a:t>탭 5: 아키텍처 비교</a:t>
-            </a:r>
-          </a:p>
-        </p:txBody>
-      </p:sp>
-      <p:sp>
-        <p:nvSpPr>
-          <p:cNvPr id="24" name="Rectangle 23"/>
+              <a:t>🔬 탭 5
+아키텍처 비교</a:t>
+            </a:r>
+          </a:p>
+        </p:txBody>
+      </p:sp>
+      <p:sp>
+        <p:nvSpPr>
+          <p:cNvPr id="27" name="Rectangle 26"/>
           <p:cNvSpPr/>
           <p:nvPr/>
         </p:nvSpPr>
         <p:spPr>
           <a:xfrm>
-            <a:off x="9692640" y="1691640"/>
-            <a:ext cx="2212848" cy="2103120"/>
+            <a:off x="10332720" y="1691640"/>
+            <a:ext cx="1737360" cy="2697480"/>
           </a:xfrm>
           <a:prstGeom prst="rect">
             <a:avLst/>
@@ -6167,14 +6332,14 @@
       </p:sp>
       <p:sp>
         <p:nvSpPr>
-          <p:cNvPr id="25" name="TextBox 24"/>
+          <p:cNvPr id="28" name="TextBox 27"/>
           <p:cNvSpPr txBox="1"/>
           <p:nvPr/>
         </p:nvSpPr>
         <p:spPr>
           <a:xfrm>
-            <a:off x="9784080" y="1783080"/>
-            <a:ext cx="2011680" cy="1920240"/>
+            <a:off x="10405872" y="1755648"/>
+            <a:ext cx="1600200" cy="2578608"/>
           </a:xfrm>
           <a:prstGeom prst="rect">
             <a:avLst/>
@@ -6189,28 +6354,30 @@
           <a:p>
             <a:pPr algn="l"/>
             <a:r>
-              <a:rPr sz="1200" b="0" i="0">
+              <a:rPr sz="1000" b="0" i="0">
                 <a:solidFill>
                   <a:srgbClr val="1A1A1A"/>
                 </a:solidFill>
                 <a:latin typeface="맑은 고딕"/>
               </a:rPr>
-              <a:t>5종 RMSE 차트
-그리드서치 결과</a:t>
-            </a:r>
-          </a:p>
-        </p:txBody>
-      </p:sp>
-      <p:sp>
-        <p:nvSpPr>
-          <p:cNvPr id="26" name="TextBox 25"/>
+              <a:t>5종 성능 비교표
+EarlyStopping 분석
+학습곡선 PNG
+OOS 예측 PNG</a:t>
+            </a:r>
+          </a:p>
+        </p:txBody>
+      </p:sp>
+      <p:sp>
+        <p:nvSpPr>
+          <p:cNvPr id="29" name="TextBox 28"/>
           <p:cNvSpPr txBox="1"/>
           <p:nvPr/>
         </p:nvSpPr>
         <p:spPr>
           <a:xfrm>
-            <a:off x="365760" y="3977639"/>
-            <a:ext cx="11430000" cy="365760"/>
+            <a:off x="274320" y="4617720"/>
+            <a:ext cx="11612880" cy="347472"/>
           </a:xfrm>
           <a:prstGeom prst="rect">
             <a:avLst/>
@@ -6238,15 +6405,15 @@
       </p:sp>
       <p:graphicFrame>
         <p:nvGraphicFramePr>
-          <p:cNvPr id="27" name="Table 26"/>
+          <p:cNvPr id="30" name="Table 29"/>
           <p:cNvGraphicFramePr>
             <a:graphicFrameLocks noGrp="1"/>
           </p:cNvGraphicFramePr>
           <p:nvPr/>
         </p:nvGraphicFramePr>
         <p:xfrm>
-          <a:off x="365760" y="4389120"/>
-          <a:ext cx="11430000" cy="2103120"/>
+          <a:off x="274320" y="5010912"/>
+          <a:ext cx="11612880" cy="1783080"/>
         </p:xfrm>
         <a:graphic>
           <a:graphicData uri="http://schemas.openxmlformats.org/drawingml/2006/table">
@@ -6255,12 +6422,12 @@
                 <a:tableStyleId>{5C22544A-7EE6-4342-B048-85BDC9FD1C3A}</a:tableStyleId>
               </a:tblPr>
               <a:tblGrid>
-                <a:gridCol w="2857500"/>
-                <a:gridCol w="2857500"/>
-                <a:gridCol w="2857500"/>
-                <a:gridCol w="2857500"/>
+                <a:gridCol w="2903220"/>
+                <a:gridCol w="2903220"/>
+                <a:gridCol w="2903220"/>
+                <a:gridCol w="2903220"/>
               </a:tblGrid>
-              <a:tr h="420624">
+              <a:tr h="356616">
                 <a:tc>
                   <a:txBody>
                     <a:bodyPr/>
@@ -6326,7 +6493,7 @@
                   </a:tcPr>
                 </a:tc>
               </a:tr>
-              <a:tr h="420624">
+              <a:tr h="356616">
                 <a:tc>
                   <a:txBody>
                     <a:bodyPr/>
@@ -6334,7 +6501,7 @@
                     <a:p>
                       <a:pPr algn="l"/>
                       <a:r>
-                        <a:rPr sz="1300">
+                        <a:rPr sz="1200">
                           <a:solidFill>
                             <a:srgbClr val="1A1A1A"/>
                           </a:solidFill>
@@ -6357,7 +6524,7 @@
                     <a:p>
                       <a:pPr algn="ctr"/>
                       <a:r>
-                        <a:rPr sz="1300">
+                        <a:rPr sz="1200">
                           <a:solidFill>
                             <a:srgbClr val="1A1A1A"/>
                           </a:solidFill>
@@ -6380,7 +6547,7 @@
                     <a:p>
                       <a:pPr algn="ctr"/>
                       <a:r>
-                        <a:rPr sz="1300">
+                        <a:rPr sz="1200">
                           <a:solidFill>
                             <a:srgbClr val="1A1A1A"/>
                           </a:solidFill>
@@ -6403,7 +6570,7 @@
                     <a:p>
                       <a:pPr algn="ctr"/>
                       <a:r>
-                        <a:rPr sz="1300">
+                        <a:rPr sz="1200">
                           <a:solidFill>
                             <a:srgbClr val="1A1A1A"/>
                           </a:solidFill>
@@ -6420,7 +6587,7 @@
                   </a:tcPr>
                 </a:tc>
               </a:tr>
-              <a:tr h="420624">
+              <a:tr h="356616">
                 <a:tc>
                   <a:txBody>
                     <a:bodyPr/>
@@ -6428,7 +6595,7 @@
                     <a:p>
                       <a:pPr algn="l"/>
                       <a:r>
-                        <a:rPr sz="1300">
+                        <a:rPr sz="1200">
                           <a:solidFill>
                             <a:srgbClr val="1A1A1A"/>
                           </a:solidFill>
@@ -6451,7 +6618,7 @@
                     <a:p>
                       <a:pPr algn="ctr"/>
                       <a:r>
-                        <a:rPr sz="1300">
+                        <a:rPr sz="1200">
                           <a:solidFill>
                             <a:srgbClr val="1A1A1A"/>
                           </a:solidFill>
@@ -6474,7 +6641,7 @@
                     <a:p>
                       <a:pPr algn="ctr"/>
                       <a:r>
-                        <a:rPr sz="1300">
+                        <a:rPr sz="1200">
                           <a:solidFill>
                             <a:srgbClr val="1A1A1A"/>
                           </a:solidFill>
@@ -6497,7 +6664,7 @@
                     <a:p>
                       <a:pPr algn="ctr"/>
                       <a:r>
-                        <a:rPr sz="1300">
+                        <a:rPr sz="1200">
                           <a:solidFill>
                             <a:srgbClr val="1A1A1A"/>
                           </a:solidFill>
@@ -6514,7 +6681,7 @@
                   </a:tcPr>
                 </a:tc>
               </a:tr>
-              <a:tr h="420624">
+              <a:tr h="356616">
                 <a:tc>
                   <a:txBody>
                     <a:bodyPr/>
@@ -6522,7 +6689,7 @@
                     <a:p>
                       <a:pPr algn="l"/>
                       <a:r>
-                        <a:rPr sz="1300">
+                        <a:rPr sz="1200">
                           <a:solidFill>
                             <a:srgbClr val="1A1A1A"/>
                           </a:solidFill>
@@ -6545,7 +6712,7 @@
                     <a:p>
                       <a:pPr algn="ctr"/>
                       <a:r>
-                        <a:rPr sz="1300">
+                        <a:rPr sz="1200">
                           <a:solidFill>
                             <a:srgbClr val="1A1A1A"/>
                           </a:solidFill>
@@ -6568,13 +6735,13 @@
                     <a:p>
                       <a:pPr algn="ctr"/>
                       <a:r>
-                        <a:rPr sz="1300">
-                          <a:solidFill>
-                            <a:srgbClr val="1A1A1A"/>
-                          </a:solidFill>
-                          <a:latin typeface="맑은 고딕"/>
-                        </a:rPr>
-                        <a:t>@st.cache_resource</a:t>
+                        <a:rPr sz="1200">
+                          <a:solidFill>
+                            <a:srgbClr val="1A1A1A"/>
+                          </a:solidFill>
+                          <a:latin typeface="맑은 고딕"/>
+                        </a:rPr>
+                        <a:t>@st.cache_resource ~0.1초</a:t>
                       </a:r>
                     </a:p>
                   </a:txBody>
@@ -6591,7 +6758,7 @@
                     <a:p>
                       <a:pPr algn="ctr"/>
                       <a:r>
-                        <a:rPr sz="1300">
+                        <a:rPr sz="1200">
                           <a:solidFill>
                             <a:srgbClr val="1A1A1A"/>
                           </a:solidFill>
@@ -6608,7 +6775,7 @@
                   </a:tcPr>
                 </a:tc>
               </a:tr>
-              <a:tr h="420624">
+              <a:tr h="356616">
                 <a:tc>
                   <a:txBody>
                     <a:bodyPr/>
@@ -6616,13 +6783,13 @@
                     <a:p>
                       <a:pPr algn="l"/>
                       <a:r>
-                        <a:rPr sz="1300">
-                          <a:solidFill>
-                            <a:srgbClr val="1A1A1A"/>
-                          </a:solidFill>
-                          <a:latin typeface="맑은 고딕"/>
-                        </a:rPr>
-                        <a:t>데이터 누수 방지</a:t>
+                        <a:rPr sz="1200">
+                          <a:solidFill>
+                            <a:srgbClr val="1A1A1A"/>
+                          </a:solidFill>
+                          <a:latin typeface="맑은 고딕"/>
+                        </a:rPr>
+                        <a:t>데이터 누수</a:t>
                       </a:r>
                     </a:p>
                   </a:txBody>
@@ -6639,7 +6806,7 @@
                     <a:p>
                       <a:pPr algn="ctr"/>
                       <a:r>
-                        <a:rPr sz="1300">
+                        <a:rPr sz="1200">
                           <a:solidFill>
                             <a:srgbClr val="1A1A1A"/>
                           </a:solidFill>
@@ -6662,7 +6829,7 @@
                     <a:p>
                       <a:pPr algn="ctr"/>
                       <a:r>
-                        <a:rPr sz="1300">
+                        <a:rPr sz="1200">
                           <a:solidFill>
                             <a:srgbClr val="1A1A1A"/>
                           </a:solidFill>
@@ -6685,7 +6852,7 @@
                     <a:p>
                       <a:pPr algn="ctr"/>
                       <a:r>
-                        <a:rPr sz="1300">
+                        <a:rPr sz="1200">
                           <a:solidFill>
                             <a:srgbClr val="1A1A1A"/>
                           </a:solidFill>
@@ -10883,6 +11050,1853 @@
                 <a:latin typeface="맑은 고딕"/>
               </a:rPr>
               <a:t>• 이상치: 말기 h_rms 급등은 열화 신호이므로 제거하지 않음</a:t>
+            </a:r>
+          </a:p>
+        </p:txBody>
+      </p:sp>
+    </p:spTree>
+  </p:cSld>
+  <p:clrMapOvr>
+    <a:masterClrMapping/>
+  </p:clrMapOvr>
+</p:sld>
+</file>
+
+<file path=ppt/slides/slide15.xml><?xml version="1.0" encoding="utf-8"?>
+<p:sld xmlns:a="http://schemas.openxmlformats.org/drawingml/2006/main" xmlns:p="http://schemas.openxmlformats.org/presentationml/2006/main" xmlns:r="http://schemas.openxmlformats.org/officeDocument/2006/relationships">
+  <p:cSld>
+    <p:spTree>
+      <p:nvGrpSpPr>
+        <p:cNvPr id="1" name=""/>
+        <p:cNvGrpSpPr/>
+        <p:nvPr/>
+      </p:nvGrpSpPr>
+      <p:grpSpPr/>
+      <p:sp>
+        <p:nvSpPr>
+          <p:cNvPr id="2" name="Rectangle 1"/>
+          <p:cNvSpPr/>
+          <p:nvPr/>
+        </p:nvSpPr>
+        <p:spPr>
+          <a:xfrm>
+            <a:off x="0" y="0"/>
+            <a:ext cx="12188952" cy="960120"/>
+          </a:xfrm>
+          <a:prstGeom prst="rect">
+            <a:avLst/>
+          </a:prstGeom>
+          <a:solidFill>
+            <a:srgbClr val="1F4E79"/>
+          </a:solidFill>
+          <a:ln>
+            <a:noFill/>
+          </a:ln>
+        </p:spPr>
+        <p:style>
+          <a:lnRef idx="1">
+            <a:schemeClr val="accent1"/>
+          </a:lnRef>
+          <a:fillRef idx="3">
+            <a:schemeClr val="accent1"/>
+          </a:fillRef>
+          <a:effectRef idx="2">
+            <a:schemeClr val="accent1"/>
+          </a:effectRef>
+          <a:fontRef idx="minor">
+            <a:schemeClr val="lt1"/>
+          </a:fontRef>
+        </p:style>
+        <p:txBody>
+          <a:bodyPr rtlCol="0" anchor="ctr"/>
+          <a:lstStyle/>
+          <a:p>
+            <a:pPr algn="ctr"/>
+          </a:p>
+        </p:txBody>
+      </p:sp>
+      <p:sp>
+        <p:nvSpPr>
+          <p:cNvPr id="3" name="Rectangle 2"/>
+          <p:cNvSpPr/>
+          <p:nvPr/>
+        </p:nvSpPr>
+        <p:spPr>
+          <a:xfrm>
+            <a:off x="0" y="6784848"/>
+            <a:ext cx="12188952" cy="73152"/>
+          </a:xfrm>
+          <a:prstGeom prst="rect">
+            <a:avLst/>
+          </a:prstGeom>
+          <a:solidFill>
+            <a:srgbClr val="2E75B6"/>
+          </a:solidFill>
+          <a:ln>
+            <a:noFill/>
+          </a:ln>
+        </p:spPr>
+        <p:style>
+          <a:lnRef idx="1">
+            <a:schemeClr val="accent1"/>
+          </a:lnRef>
+          <a:fillRef idx="3">
+            <a:schemeClr val="accent1"/>
+          </a:fillRef>
+          <a:effectRef idx="2">
+            <a:schemeClr val="accent1"/>
+          </a:effectRef>
+          <a:fontRef idx="minor">
+            <a:schemeClr val="lt1"/>
+          </a:fontRef>
+        </p:style>
+        <p:txBody>
+          <a:bodyPr rtlCol="0" anchor="ctr"/>
+          <a:lstStyle/>
+          <a:p>
+            <a:pPr algn="ctr"/>
+          </a:p>
+        </p:txBody>
+      </p:sp>
+      <p:sp>
+        <p:nvSpPr>
+          <p:cNvPr id="4" name="TextBox 3"/>
+          <p:cNvSpPr txBox="1"/>
+          <p:nvPr/>
+        </p:nvSpPr>
+        <p:spPr>
+          <a:xfrm>
+            <a:off x="274320" y="54864"/>
+            <a:ext cx="10058400" cy="594360"/>
+          </a:xfrm>
+          <a:prstGeom prst="rect">
+            <a:avLst/>
+          </a:prstGeom>
+          <a:noFill/>
+        </p:spPr>
+        <p:txBody>
+          <a:bodyPr wrap="square">
+            <a:spAutoFit/>
+          </a:bodyPr>
+          <a:lstStyle/>
+          <a:p>
+            <a:pPr algn="l"/>
+            <a:r>
+              <a:rPr sz="2600" b="1" i="0">
+                <a:solidFill>
+                  <a:srgbClr val="FFFFFF"/>
+                </a:solidFill>
+                <a:latin typeface="맑은 고딕"/>
+              </a:rPr>
+              <a:t>Confusion Matrix — DL 이진 분류 결과</a:t>
+            </a:r>
+          </a:p>
+        </p:txBody>
+      </p:sp>
+      <p:sp>
+        <p:nvSpPr>
+          <p:cNvPr id="5" name="TextBox 4"/>
+          <p:cNvSpPr txBox="1"/>
+          <p:nvPr/>
+        </p:nvSpPr>
+        <p:spPr>
+          <a:xfrm>
+            <a:off x="320040" y="621792"/>
+            <a:ext cx="11430000" cy="320040"/>
+          </a:xfrm>
+          <a:prstGeom prst="rect">
+            <a:avLst/>
+          </a:prstGeom>
+          <a:noFill/>
+        </p:spPr>
+        <p:txBody>
+          <a:bodyPr wrap="square">
+            <a:spAutoFit/>
+          </a:bodyPr>
+          <a:lstStyle/>
+          <a:p>
+            <a:pPr algn="l"/>
+            <a:r>
+              <a:rPr sz="1200" b="0" i="1">
+                <a:solidFill>
+                  <a:srgbClr val="BDD7EE"/>
+                </a:solidFill>
+                <a:latin typeface="맑은 고딕"/>
+              </a:rPr>
+              <a:t>CNN+LSTM (Validation Set, 179 samples)  ·  Threshold = 0.50  ·  Accuracy = 0.80</a:t>
+            </a:r>
+          </a:p>
+        </p:txBody>
+      </p:sp>
+      <p:pic>
+        <p:nvPicPr>
+          <p:cNvPr id="6" name="Picture 5" descr="05_conf.png"/>
+          <p:cNvPicPr>
+            <a:picLocks noChangeAspect="1"/>
+          </p:cNvPicPr>
+          <p:nvPr/>
+        </p:nvPicPr>
+        <p:blipFill>
+          <a:blip r:embed="rId2"/>
+          <a:stretch>
+            <a:fillRect/>
+          </a:stretch>
+        </p:blipFill>
+        <p:spPr>
+          <a:xfrm>
+            <a:off x="274320" y="1051560"/>
+            <a:ext cx="5303520" cy="5029200"/>
+          </a:xfrm>
+          <a:prstGeom prst="rect">
+            <a:avLst/>
+          </a:prstGeom>
+        </p:spPr>
+      </p:pic>
+      <p:sp>
+        <p:nvSpPr>
+          <p:cNvPr id="7" name="TextBox 6"/>
+          <p:cNvSpPr txBox="1"/>
+          <p:nvPr/>
+        </p:nvSpPr>
+        <p:spPr>
+          <a:xfrm>
+            <a:off x="5852160" y="1051560"/>
+            <a:ext cx="6126480" cy="365760"/>
+          </a:xfrm>
+          <a:prstGeom prst="rect">
+            <a:avLst/>
+          </a:prstGeom>
+          <a:noFill/>
+        </p:spPr>
+        <p:txBody>
+          <a:bodyPr wrap="square">
+            <a:spAutoFit/>
+          </a:bodyPr>
+          <a:lstStyle/>
+          <a:p>
+            <a:pPr algn="l"/>
+            <a:r>
+              <a:rPr sz="1300" b="1" i="0">
+                <a:solidFill>
+                  <a:srgbClr val="1F4E79"/>
+                </a:solidFill>
+                <a:latin typeface="맑은 고딕"/>
+              </a:rPr>
+              <a:t>Confusion Matrix 수치</a:t>
+            </a:r>
+          </a:p>
+        </p:txBody>
+      </p:sp>
+      <p:graphicFrame>
+        <p:nvGraphicFramePr>
+          <p:cNvPr id="8" name="Table 7"/>
+          <p:cNvGraphicFramePr>
+            <a:graphicFrameLocks noGrp="1"/>
+          </p:cNvGraphicFramePr>
+          <p:nvPr/>
+        </p:nvGraphicFramePr>
+        <p:xfrm>
+          <a:off x="5852160" y="1463040"/>
+          <a:ext cx="6126480" cy="1188720"/>
+        </p:xfrm>
+        <a:graphic>
+          <a:graphicData uri="http://schemas.openxmlformats.org/drawingml/2006/table">
+            <a:tbl>
+              <a:tblPr firstRow="1" bandRow="1">
+                <a:tableStyleId>{5C22544A-7EE6-4342-B048-85BDC9FD1C3A}</a:tableStyleId>
+              </a:tblPr>
+              <a:tblGrid>
+                <a:gridCol w="2042160"/>
+                <a:gridCol w="2042160"/>
+                <a:gridCol w="2042160"/>
+              </a:tblGrid>
+              <a:tr h="396240">
+                <a:tc>
+                  <a:txBody>
+                    <a:bodyPr/>
+                    <a:lstStyle/>
+                    <a:p/>
+                  </a:txBody>
+                  <a:tcPr>
+                    <a:solidFill>
+                      <a:srgbClr val="1F4E79"/>
+                    </a:solidFill>
+                  </a:tcPr>
+                </a:tc>
+                <a:tc>
+                  <a:txBody>
+                    <a:bodyPr/>
+                    <a:lstStyle/>
+                    <a:p>
+                      <a:r>
+                        <a:t>예측: 정상(0)</a:t>
+                      </a:r>
+                    </a:p>
+                  </a:txBody>
+                  <a:tcPr>
+                    <a:solidFill>
+                      <a:srgbClr val="1F4E79"/>
+                    </a:solidFill>
+                  </a:tcPr>
+                </a:tc>
+                <a:tc>
+                  <a:txBody>
+                    <a:bodyPr/>
+                    <a:lstStyle/>
+                    <a:p>
+                      <a:r>
+                        <a:t>예측: 고장(1)</a:t>
+                      </a:r>
+                    </a:p>
+                  </a:txBody>
+                  <a:tcPr>
+                    <a:solidFill>
+                      <a:srgbClr val="1F4E79"/>
+                    </a:solidFill>
+                  </a:tcPr>
+                </a:tc>
+              </a:tr>
+              <a:tr h="396240">
+                <a:tc>
+                  <a:txBody>
+                    <a:bodyPr/>
+                    <a:lstStyle/>
+                    <a:p>
+                      <a:pPr algn="l"/>
+                      <a:r>
+                        <a:rPr sz="1300">
+                          <a:solidFill>
+                            <a:srgbClr val="1A1A1A"/>
+                          </a:solidFill>
+                          <a:latin typeface="맑은 고딕"/>
+                        </a:rPr>
+                        <a:t>실제: 정상(0)</a:t>
+                      </a:r>
+                    </a:p>
+                  </a:txBody>
+                  <a:tcPr>
+                    <a:solidFill>
+                      <a:srgbClr val="FFFFFF"/>
+                    </a:solidFill>
+                  </a:tcPr>
+                </a:tc>
+                <a:tc>
+                  <a:txBody>
+                    <a:bodyPr/>
+                    <a:lstStyle/>
+                    <a:p>
+                      <a:pPr algn="ctr"/>
+                      <a:r>
+                        <a:rPr sz="1300">
+                          <a:solidFill>
+                            <a:srgbClr val="1A1A1A"/>
+                          </a:solidFill>
+                          <a:latin typeface="맑은 고딕"/>
+                        </a:rPr>
+                        <a:t>TN = 93 ✓</a:t>
+                      </a:r>
+                    </a:p>
+                  </a:txBody>
+                  <a:tcPr>
+                    <a:solidFill>
+                      <a:srgbClr val="FFFFFF"/>
+                    </a:solidFill>
+                  </a:tcPr>
+                </a:tc>
+                <a:tc>
+                  <a:txBody>
+                    <a:bodyPr/>
+                    <a:lstStyle/>
+                    <a:p>
+                      <a:pPr algn="ctr"/>
+                      <a:r>
+                        <a:rPr sz="1300">
+                          <a:solidFill>
+                            <a:srgbClr val="1A1A1A"/>
+                          </a:solidFill>
+                          <a:latin typeface="맑은 고딕"/>
+                        </a:rPr>
+                        <a:t>FP = 12 ⚠</a:t>
+                      </a:r>
+                    </a:p>
+                  </a:txBody>
+                  <a:tcPr>
+                    <a:solidFill>
+                      <a:srgbClr val="FFFFFF"/>
+                    </a:solidFill>
+                  </a:tcPr>
+                </a:tc>
+              </a:tr>
+              <a:tr h="396240">
+                <a:tc>
+                  <a:txBody>
+                    <a:bodyPr/>
+                    <a:lstStyle/>
+                    <a:p>
+                      <a:pPr algn="l"/>
+                      <a:r>
+                        <a:rPr sz="1300">
+                          <a:solidFill>
+                            <a:srgbClr val="1A1A1A"/>
+                          </a:solidFill>
+                          <a:latin typeface="맑은 고딕"/>
+                        </a:rPr>
+                        <a:t>실제: 고장(1)</a:t>
+                      </a:r>
+                    </a:p>
+                  </a:txBody>
+                  <a:tcPr>
+                    <a:solidFill>
+                      <a:srgbClr val="FFE0E0"/>
+                    </a:solidFill>
+                  </a:tcPr>
+                </a:tc>
+                <a:tc>
+                  <a:txBody>
+                    <a:bodyPr/>
+                    <a:lstStyle/>
+                    <a:p>
+                      <a:pPr algn="ctr"/>
+                      <a:r>
+                        <a:rPr sz="1300">
+                          <a:solidFill>
+                            <a:srgbClr val="1A1A1A"/>
+                          </a:solidFill>
+                          <a:latin typeface="맑은 고딕"/>
+                        </a:rPr>
+                        <a:t>FN = 24 ✗</a:t>
+                      </a:r>
+                    </a:p>
+                  </a:txBody>
+                  <a:tcPr>
+                    <a:solidFill>
+                      <a:srgbClr val="FFE0E0"/>
+                    </a:solidFill>
+                  </a:tcPr>
+                </a:tc>
+                <a:tc>
+                  <a:txBody>
+                    <a:bodyPr/>
+                    <a:lstStyle/>
+                    <a:p>
+                      <a:pPr algn="ctr"/>
+                      <a:r>
+                        <a:rPr sz="1300">
+                          <a:solidFill>
+                            <a:srgbClr val="1A1A1A"/>
+                          </a:solidFill>
+                          <a:latin typeface="맑은 고딕"/>
+                        </a:rPr>
+                        <a:t>TP = 50 ✓</a:t>
+                      </a:r>
+                    </a:p>
+                  </a:txBody>
+                  <a:tcPr>
+                    <a:solidFill>
+                      <a:srgbClr val="FFE0E0"/>
+                    </a:solidFill>
+                  </a:tcPr>
+                </a:tc>
+              </a:tr>
+            </a:tbl>
+          </a:graphicData>
+        </a:graphic>
+      </p:graphicFrame>
+      <p:sp>
+        <p:nvSpPr>
+          <p:cNvPr id="9" name="TextBox 8"/>
+          <p:cNvSpPr txBox="1"/>
+          <p:nvPr/>
+        </p:nvSpPr>
+        <p:spPr>
+          <a:xfrm>
+            <a:off x="5852160" y="2788920"/>
+            <a:ext cx="6126480" cy="365760"/>
+          </a:xfrm>
+          <a:prstGeom prst="rect">
+            <a:avLst/>
+          </a:prstGeom>
+          <a:noFill/>
+        </p:spPr>
+        <p:txBody>
+          <a:bodyPr wrap="square">
+            <a:spAutoFit/>
+          </a:bodyPr>
+          <a:lstStyle/>
+          <a:p>
+            <a:pPr algn="l"/>
+            <a:r>
+              <a:rPr sz="1300" b="1" i="0">
+                <a:solidFill>
+                  <a:srgbClr val="1F4E79"/>
+                </a:solidFill>
+                <a:latin typeface="맑은 고딕"/>
+              </a:rPr>
+              <a:t>분류 성능 지표</a:t>
+            </a:r>
+          </a:p>
+        </p:txBody>
+      </p:sp>
+      <p:graphicFrame>
+        <p:nvGraphicFramePr>
+          <p:cNvPr id="10" name="Table 9"/>
+          <p:cNvGraphicFramePr>
+            <a:graphicFrameLocks noGrp="1"/>
+          </p:cNvGraphicFramePr>
+          <p:nvPr/>
+        </p:nvGraphicFramePr>
+        <p:xfrm>
+          <a:off x="5852160" y="3200400"/>
+          <a:ext cx="6126480" cy="1234440"/>
+        </p:xfrm>
+        <a:graphic>
+          <a:graphicData uri="http://schemas.openxmlformats.org/drawingml/2006/table">
+            <a:tbl>
+              <a:tblPr firstRow="1" bandRow="1">
+                <a:tableStyleId>{5C22544A-7EE6-4342-B048-85BDC9FD1C3A}</a:tableStyleId>
+              </a:tblPr>
+              <a:tblGrid>
+                <a:gridCol w="2042160"/>
+                <a:gridCol w="2042160"/>
+                <a:gridCol w="2042160"/>
+              </a:tblGrid>
+              <a:tr h="308610">
+                <a:tc>
+                  <a:txBody>
+                    <a:bodyPr/>
+                    <a:lstStyle/>
+                    <a:p>
+                      <a:r>
+                        <a:t>지표</a:t>
+                      </a:r>
+                    </a:p>
+                  </a:txBody>
+                  <a:tcPr>
+                    <a:solidFill>
+                      <a:srgbClr val="1F4E79"/>
+                    </a:solidFill>
+                  </a:tcPr>
+                </a:tc>
+                <a:tc>
+                  <a:txBody>
+                    <a:bodyPr/>
+                    <a:lstStyle/>
+                    <a:p>
+                      <a:r>
+                        <a:t>클래스 0 (정상)</a:t>
+                      </a:r>
+                    </a:p>
+                  </a:txBody>
+                  <a:tcPr>
+                    <a:solidFill>
+                      <a:srgbClr val="1F4E79"/>
+                    </a:solidFill>
+                  </a:tcPr>
+                </a:tc>
+                <a:tc>
+                  <a:txBody>
+                    <a:bodyPr/>
+                    <a:lstStyle/>
+                    <a:p>
+                      <a:r>
+                        <a:t>클래스 1 (고장)</a:t>
+                      </a:r>
+                    </a:p>
+                  </a:txBody>
+                  <a:tcPr>
+                    <a:solidFill>
+                      <a:srgbClr val="1F4E79"/>
+                    </a:solidFill>
+                  </a:tcPr>
+                </a:tc>
+              </a:tr>
+              <a:tr h="308610">
+                <a:tc>
+                  <a:txBody>
+                    <a:bodyPr/>
+                    <a:lstStyle/>
+                    <a:p>
+                      <a:pPr algn="l"/>
+                      <a:r>
+                        <a:rPr sz="1200">
+                          <a:solidFill>
+                            <a:srgbClr val="1A1A1A"/>
+                          </a:solidFill>
+                          <a:latin typeface="맑은 고딕"/>
+                        </a:rPr>
+                        <a:t>Precision</a:t>
+                      </a:r>
+                    </a:p>
+                  </a:txBody>
+                  <a:tcPr>
+                    <a:solidFill>
+                      <a:srgbClr val="FFFFFF"/>
+                    </a:solidFill>
+                  </a:tcPr>
+                </a:tc>
+                <a:tc>
+                  <a:txBody>
+                    <a:bodyPr/>
+                    <a:lstStyle/>
+                    <a:p>
+                      <a:pPr algn="ctr"/>
+                      <a:r>
+                        <a:rPr sz="1200">
+                          <a:solidFill>
+                            <a:srgbClr val="1A1A1A"/>
+                          </a:solidFill>
+                          <a:latin typeface="맑은 고딕"/>
+                        </a:rPr>
+                        <a:t>0.79  (93/(93+24))</a:t>
+                      </a:r>
+                    </a:p>
+                  </a:txBody>
+                  <a:tcPr>
+                    <a:solidFill>
+                      <a:srgbClr val="FFFFFF"/>
+                    </a:solidFill>
+                  </a:tcPr>
+                </a:tc>
+                <a:tc>
+                  <a:txBody>
+                    <a:bodyPr/>
+                    <a:lstStyle/>
+                    <a:p>
+                      <a:pPr algn="ctr"/>
+                      <a:r>
+                        <a:rPr sz="1200">
+                          <a:solidFill>
+                            <a:srgbClr val="1A1A1A"/>
+                          </a:solidFill>
+                          <a:latin typeface="맑은 고딕"/>
+                        </a:rPr>
+                        <a:t>0.81  (50/(50+12))</a:t>
+                      </a:r>
+                    </a:p>
+                  </a:txBody>
+                  <a:tcPr>
+                    <a:solidFill>
+                      <a:srgbClr val="FFFFFF"/>
+                    </a:solidFill>
+                  </a:tcPr>
+                </a:tc>
+              </a:tr>
+              <a:tr h="308610">
+                <a:tc>
+                  <a:txBody>
+                    <a:bodyPr/>
+                    <a:lstStyle/>
+                    <a:p>
+                      <a:pPr algn="l"/>
+                      <a:r>
+                        <a:rPr sz="1200">
+                          <a:solidFill>
+                            <a:srgbClr val="1A1A1A"/>
+                          </a:solidFill>
+                          <a:latin typeface="맑은 고딕"/>
+                        </a:rPr>
+                        <a:t>Recall</a:t>
+                      </a:r>
+                    </a:p>
+                  </a:txBody>
+                  <a:tcPr>
+                    <a:solidFill>
+                      <a:srgbClr val="FFE0E0"/>
+                    </a:solidFill>
+                  </a:tcPr>
+                </a:tc>
+                <a:tc>
+                  <a:txBody>
+                    <a:bodyPr/>
+                    <a:lstStyle/>
+                    <a:p>
+                      <a:pPr algn="ctr"/>
+                      <a:r>
+                        <a:rPr sz="1200">
+                          <a:solidFill>
+                            <a:srgbClr val="1A1A1A"/>
+                          </a:solidFill>
+                          <a:latin typeface="맑은 고딕"/>
+                        </a:rPr>
+                        <a:t>0.89  (93/(93+12))</a:t>
+                      </a:r>
+                    </a:p>
+                  </a:txBody>
+                  <a:tcPr>
+                    <a:solidFill>
+                      <a:srgbClr val="FFE0E0"/>
+                    </a:solidFill>
+                  </a:tcPr>
+                </a:tc>
+                <a:tc>
+                  <a:txBody>
+                    <a:bodyPr/>
+                    <a:lstStyle/>
+                    <a:p>
+                      <a:pPr algn="ctr"/>
+                      <a:r>
+                        <a:rPr sz="1200">
+                          <a:solidFill>
+                            <a:srgbClr val="1A1A1A"/>
+                          </a:solidFill>
+                          <a:latin typeface="맑은 고딕"/>
+                        </a:rPr>
+                        <a:t>0.68  (50/(50+24)) ↓</a:t>
+                      </a:r>
+                    </a:p>
+                  </a:txBody>
+                  <a:tcPr>
+                    <a:solidFill>
+                      <a:srgbClr val="FFE0E0"/>
+                    </a:solidFill>
+                  </a:tcPr>
+                </a:tc>
+              </a:tr>
+              <a:tr h="308610">
+                <a:tc>
+                  <a:txBody>
+                    <a:bodyPr/>
+                    <a:lstStyle/>
+                    <a:p>
+                      <a:pPr algn="l"/>
+                      <a:r>
+                        <a:rPr sz="1200">
+                          <a:solidFill>
+                            <a:srgbClr val="1A1A1A"/>
+                          </a:solidFill>
+                          <a:latin typeface="맑은 고딕"/>
+                        </a:rPr>
+                        <a:t>F1-Score</a:t>
+                      </a:r>
+                    </a:p>
+                  </a:txBody>
+                  <a:tcPr>
+                    <a:solidFill>
+                      <a:srgbClr val="F2F2F2"/>
+                    </a:solidFill>
+                  </a:tcPr>
+                </a:tc>
+                <a:tc>
+                  <a:txBody>
+                    <a:bodyPr/>
+                    <a:lstStyle/>
+                    <a:p>
+                      <a:pPr algn="ctr"/>
+                      <a:r>
+                        <a:rPr sz="1200">
+                          <a:solidFill>
+                            <a:srgbClr val="1A1A1A"/>
+                          </a:solidFill>
+                          <a:latin typeface="맑은 고딕"/>
+                        </a:rPr>
+                        <a:t>0.84</a:t>
+                      </a:r>
+                    </a:p>
+                  </a:txBody>
+                  <a:tcPr>
+                    <a:solidFill>
+                      <a:srgbClr val="F2F2F2"/>
+                    </a:solidFill>
+                  </a:tcPr>
+                </a:tc>
+                <a:tc>
+                  <a:txBody>
+                    <a:bodyPr/>
+                    <a:lstStyle/>
+                    <a:p>
+                      <a:pPr algn="ctr"/>
+                      <a:r>
+                        <a:rPr sz="1200">
+                          <a:solidFill>
+                            <a:srgbClr val="1A1A1A"/>
+                          </a:solidFill>
+                          <a:latin typeface="맑은 고딕"/>
+                        </a:rPr>
+                        <a:t>0.74</a:t>
+                      </a:r>
+                    </a:p>
+                  </a:txBody>
+                  <a:tcPr>
+                    <a:solidFill>
+                      <a:srgbClr val="F2F2F2"/>
+                    </a:solidFill>
+                  </a:tcPr>
+                </a:tc>
+              </a:tr>
+            </a:tbl>
+          </a:graphicData>
+        </a:graphic>
+      </p:graphicFrame>
+      <p:sp>
+        <p:nvSpPr>
+          <p:cNvPr id="11" name="Rectangle 10"/>
+          <p:cNvSpPr/>
+          <p:nvPr/>
+        </p:nvSpPr>
+        <p:spPr>
+          <a:xfrm>
+            <a:off x="5852160" y="4572000"/>
+            <a:ext cx="6126480" cy="1554480"/>
+          </a:xfrm>
+          <a:prstGeom prst="rect">
+            <a:avLst/>
+          </a:prstGeom>
+          <a:solidFill>
+            <a:srgbClr val="D6E4F7"/>
+          </a:solidFill>
+          <a:ln>
+            <a:noFill/>
+          </a:ln>
+        </p:spPr>
+        <p:style>
+          <a:lnRef idx="1">
+            <a:schemeClr val="accent1"/>
+          </a:lnRef>
+          <a:fillRef idx="3">
+            <a:schemeClr val="accent1"/>
+          </a:fillRef>
+          <a:effectRef idx="2">
+            <a:schemeClr val="accent1"/>
+          </a:effectRef>
+          <a:fontRef idx="minor">
+            <a:schemeClr val="lt1"/>
+          </a:fontRef>
+        </p:style>
+        <p:txBody>
+          <a:bodyPr rtlCol="0" anchor="ctr"/>
+          <a:lstStyle/>
+          <a:p>
+            <a:pPr algn="ctr"/>
+          </a:p>
+        </p:txBody>
+      </p:sp>
+      <p:sp>
+        <p:nvSpPr>
+          <p:cNvPr id="12" name="TextBox 11"/>
+          <p:cNvSpPr txBox="1"/>
+          <p:nvPr/>
+        </p:nvSpPr>
+        <p:spPr>
+          <a:xfrm>
+            <a:off x="5943600" y="4617720"/>
+            <a:ext cx="5943600" cy="365760"/>
+          </a:xfrm>
+          <a:prstGeom prst="rect">
+            <a:avLst/>
+          </a:prstGeom>
+          <a:noFill/>
+        </p:spPr>
+        <p:txBody>
+          <a:bodyPr wrap="square">
+            <a:spAutoFit/>
+          </a:bodyPr>
+          <a:lstStyle/>
+          <a:p>
+            <a:pPr algn="l"/>
+            <a:r>
+              <a:rPr sz="1200" b="1" i="0">
+                <a:solidFill>
+                  <a:srgbClr val="1F4E79"/>
+                </a:solidFill>
+                <a:latin typeface="맑은 고딕"/>
+              </a:rPr>
+              <a:t>핵심 문제: FN = 24 (미감지) 가 더 심각</a:t>
+            </a:r>
+          </a:p>
+        </p:txBody>
+      </p:sp>
+      <p:sp>
+        <p:nvSpPr>
+          <p:cNvPr id="13" name="TextBox 12"/>
+          <p:cNvSpPr txBox="1"/>
+          <p:nvPr/>
+        </p:nvSpPr>
+        <p:spPr>
+          <a:xfrm>
+            <a:off x="5943600" y="5029200"/>
+            <a:ext cx="5943600" cy="1051560"/>
+          </a:xfrm>
+          <a:prstGeom prst="rect">
+            <a:avLst/>
+          </a:prstGeom>
+          <a:noFill/>
+        </p:spPr>
+        <p:txBody>
+          <a:bodyPr wrap="square">
+            <a:spAutoFit/>
+          </a:bodyPr>
+          <a:lstStyle/>
+          <a:p>
+            <a:pPr algn="l"/>
+            <a:r>
+              <a:rPr sz="1150" b="0" i="0">
+                <a:solidFill>
+                  <a:srgbClr val="1A1A1A"/>
+                </a:solidFill>
+                <a:latin typeface="맑은 고딕"/>
+              </a:rPr>
+              <a:t>• FP 12건: 정상 → 고장 오판 → 불필요한 점검 (비용↑, 안전 무관)
+• FN 24건: 실제 고장 미감지 → 설비 손상·라인 정지 위험 ★
+• Class 1 Recall 0.68 → 고장 32% 놓침 → 개선 필요
+• Threshold 0.50→0.35 하향 시 FN 대폭 감소 가능</a:t>
+            </a:r>
+          </a:p>
+        </p:txBody>
+      </p:sp>
+    </p:spTree>
+  </p:cSld>
+  <p:clrMapOvr>
+    <a:masterClrMapping/>
+  </p:clrMapOvr>
+</p:sld>
+</file>
+
+<file path=ppt/slides/slide16.xml><?xml version="1.0" encoding="utf-8"?>
+<p:sld xmlns:a="http://schemas.openxmlformats.org/drawingml/2006/main" xmlns:p="http://schemas.openxmlformats.org/presentationml/2006/main" xmlns:r="http://schemas.openxmlformats.org/officeDocument/2006/relationships">
+  <p:cSld>
+    <p:spTree>
+      <p:nvGrpSpPr>
+        <p:cNvPr id="1" name=""/>
+        <p:cNvGrpSpPr/>
+        <p:nvPr/>
+      </p:nvGrpSpPr>
+      <p:grpSpPr/>
+      <p:sp>
+        <p:nvSpPr>
+          <p:cNvPr id="2" name="Rectangle 1"/>
+          <p:cNvSpPr/>
+          <p:nvPr/>
+        </p:nvSpPr>
+        <p:spPr>
+          <a:xfrm>
+            <a:off x="0" y="0"/>
+            <a:ext cx="12188952" cy="960120"/>
+          </a:xfrm>
+          <a:prstGeom prst="rect">
+            <a:avLst/>
+          </a:prstGeom>
+          <a:solidFill>
+            <a:srgbClr val="1F4E79"/>
+          </a:solidFill>
+          <a:ln>
+            <a:noFill/>
+          </a:ln>
+        </p:spPr>
+        <p:style>
+          <a:lnRef idx="1">
+            <a:schemeClr val="accent1"/>
+          </a:lnRef>
+          <a:fillRef idx="3">
+            <a:schemeClr val="accent1"/>
+          </a:fillRef>
+          <a:effectRef idx="2">
+            <a:schemeClr val="accent1"/>
+          </a:effectRef>
+          <a:fontRef idx="minor">
+            <a:schemeClr val="lt1"/>
+          </a:fontRef>
+        </p:style>
+        <p:txBody>
+          <a:bodyPr rtlCol="0" anchor="ctr"/>
+          <a:lstStyle/>
+          <a:p>
+            <a:pPr algn="ctr"/>
+          </a:p>
+        </p:txBody>
+      </p:sp>
+      <p:sp>
+        <p:nvSpPr>
+          <p:cNvPr id="3" name="Rectangle 2"/>
+          <p:cNvSpPr/>
+          <p:nvPr/>
+        </p:nvSpPr>
+        <p:spPr>
+          <a:xfrm>
+            <a:off x="0" y="6784848"/>
+            <a:ext cx="12188952" cy="73152"/>
+          </a:xfrm>
+          <a:prstGeom prst="rect">
+            <a:avLst/>
+          </a:prstGeom>
+          <a:solidFill>
+            <a:srgbClr val="2E75B6"/>
+          </a:solidFill>
+          <a:ln>
+            <a:noFill/>
+          </a:ln>
+        </p:spPr>
+        <p:style>
+          <a:lnRef idx="1">
+            <a:schemeClr val="accent1"/>
+          </a:lnRef>
+          <a:fillRef idx="3">
+            <a:schemeClr val="accent1"/>
+          </a:fillRef>
+          <a:effectRef idx="2">
+            <a:schemeClr val="accent1"/>
+          </a:effectRef>
+          <a:fontRef idx="minor">
+            <a:schemeClr val="lt1"/>
+          </a:fontRef>
+        </p:style>
+        <p:txBody>
+          <a:bodyPr rtlCol="0" anchor="ctr"/>
+          <a:lstStyle/>
+          <a:p>
+            <a:pPr algn="ctr"/>
+          </a:p>
+        </p:txBody>
+      </p:sp>
+      <p:sp>
+        <p:nvSpPr>
+          <p:cNvPr id="4" name="TextBox 3"/>
+          <p:cNvSpPr txBox="1"/>
+          <p:nvPr/>
+        </p:nvSpPr>
+        <p:spPr>
+          <a:xfrm>
+            <a:off x="274320" y="54864"/>
+            <a:ext cx="10058400" cy="594360"/>
+          </a:xfrm>
+          <a:prstGeom prst="rect">
+            <a:avLst/>
+          </a:prstGeom>
+          <a:noFill/>
+        </p:spPr>
+        <p:txBody>
+          <a:bodyPr wrap="square">
+            <a:spAutoFit/>
+          </a:bodyPr>
+          <a:lstStyle/>
+          <a:p>
+            <a:pPr algn="l"/>
+            <a:r>
+              <a:rPr sz="2600" b="1" i="0">
+                <a:solidFill>
+                  <a:srgbClr val="FFFFFF"/>
+                </a:solidFill>
+                <a:latin typeface="맑은 고딕"/>
+              </a:rPr>
+              <a:t>FP / FN 개선 방향 분석</a:t>
+            </a:r>
+          </a:p>
+        </p:txBody>
+      </p:sp>
+      <p:sp>
+        <p:nvSpPr>
+          <p:cNvPr id="5" name="TextBox 4"/>
+          <p:cNvSpPr txBox="1"/>
+          <p:nvPr/>
+        </p:nvSpPr>
+        <p:spPr>
+          <a:xfrm>
+            <a:off x="320040" y="621792"/>
+            <a:ext cx="11430000" cy="320040"/>
+          </a:xfrm>
+          <a:prstGeom prst="rect">
+            <a:avLst/>
+          </a:prstGeom>
+          <a:noFill/>
+        </p:spPr>
+        <p:txBody>
+          <a:bodyPr wrap="square">
+            <a:spAutoFit/>
+          </a:bodyPr>
+          <a:lstStyle/>
+          <a:p>
+            <a:pPr algn="l"/>
+            <a:r>
+              <a:rPr sz="1200" b="0" i="1">
+                <a:solidFill>
+                  <a:srgbClr val="BDD7EE"/>
+                </a:solidFill>
+                <a:latin typeface="맑은 고딕"/>
+              </a:rPr>
+              <a:t>False Positive(오경보) vs False Negative(미감지)  ·  우선순위 기반 개선 로드맵</a:t>
+            </a:r>
+          </a:p>
+        </p:txBody>
+      </p:sp>
+      <p:sp>
+        <p:nvSpPr>
+          <p:cNvPr id="6" name="Rectangle 5"/>
+          <p:cNvSpPr/>
+          <p:nvPr/>
+        </p:nvSpPr>
+        <p:spPr>
+          <a:xfrm>
+            <a:off x="274320" y="1051560"/>
+            <a:ext cx="11612880" cy="777240"/>
+          </a:xfrm>
+          <a:prstGeom prst="rect">
+            <a:avLst/>
+          </a:prstGeom>
+          <a:solidFill>
+            <a:srgbClr val="D6E4F7"/>
+          </a:solidFill>
+          <a:ln>
+            <a:noFill/>
+          </a:ln>
+        </p:spPr>
+        <p:style>
+          <a:lnRef idx="1">
+            <a:schemeClr val="accent1"/>
+          </a:lnRef>
+          <a:fillRef idx="3">
+            <a:schemeClr val="accent1"/>
+          </a:fillRef>
+          <a:effectRef idx="2">
+            <a:schemeClr val="accent1"/>
+          </a:effectRef>
+          <a:fontRef idx="minor">
+            <a:schemeClr val="lt1"/>
+          </a:fontRef>
+        </p:style>
+        <p:txBody>
+          <a:bodyPr rtlCol="0" anchor="ctr"/>
+          <a:lstStyle/>
+          <a:p>
+            <a:pPr algn="ctr"/>
+          </a:p>
+        </p:txBody>
+      </p:sp>
+      <p:sp>
+        <p:nvSpPr>
+          <p:cNvPr id="7" name="TextBox 6"/>
+          <p:cNvSpPr txBox="1"/>
+          <p:nvPr/>
+        </p:nvSpPr>
+        <p:spPr>
+          <a:xfrm>
+            <a:off x="365760" y="1078992"/>
+            <a:ext cx="11430000" cy="347472"/>
+          </a:xfrm>
+          <a:prstGeom prst="rect">
+            <a:avLst/>
+          </a:prstGeom>
+          <a:noFill/>
+        </p:spPr>
+        <p:txBody>
+          <a:bodyPr wrap="square">
+            <a:spAutoFit/>
+          </a:bodyPr>
+          <a:lstStyle/>
+          <a:p>
+            <a:pPr algn="l"/>
+            <a:r>
+              <a:rPr sz="1300" b="1" i="0">
+                <a:solidFill>
+                  <a:srgbClr val="1F4E79"/>
+                </a:solidFill>
+                <a:latin typeface="맑은 고딕"/>
+              </a:rPr>
+              <a:t>오경보(FP) vs 미감지(FN) — 제조업 관점</a:t>
+            </a:r>
+          </a:p>
+        </p:txBody>
+      </p:sp>
+      <p:sp>
+        <p:nvSpPr>
+          <p:cNvPr id="8" name="TextBox 7"/>
+          <p:cNvSpPr txBox="1"/>
+          <p:nvPr/>
+        </p:nvSpPr>
+        <p:spPr>
+          <a:xfrm>
+            <a:off x="365760" y="1435608"/>
+            <a:ext cx="11430000" cy="347472"/>
+          </a:xfrm>
+          <a:prstGeom prst="rect">
+            <a:avLst/>
+          </a:prstGeom>
+          <a:noFill/>
+        </p:spPr>
+        <p:txBody>
+          <a:bodyPr wrap="square">
+            <a:spAutoFit/>
+          </a:bodyPr>
+          <a:lstStyle/>
+          <a:p>
+            <a:pPr algn="l"/>
+            <a:r>
+              <a:rPr sz="1150" b="0" i="0">
+                <a:solidFill>
+                  <a:srgbClr val="1A1A1A"/>
+                </a:solidFill>
+                <a:latin typeface="맑은 고딕"/>
+              </a:rPr>
+              <a:t>FP(오경보): 안전 측면 위험 없음, 불필요한 유지보수 비용 발생  |  FN(미감지): 실제 고장 방치 → 설비 파손·생산 중단 → 비용/안전 모두 위험 ★★★</a:t>
+            </a:r>
+          </a:p>
+        </p:txBody>
+      </p:sp>
+      <p:sp>
+        <p:nvSpPr>
+          <p:cNvPr id="9" name="Rectangle 8"/>
+          <p:cNvSpPr/>
+          <p:nvPr/>
+        </p:nvSpPr>
+        <p:spPr>
+          <a:xfrm>
+            <a:off x="274320" y="1965960"/>
+            <a:ext cx="5394960" cy="4114800"/>
+          </a:xfrm>
+          <a:prstGeom prst="rect">
+            <a:avLst/>
+          </a:prstGeom>
+          <a:solidFill>
+            <a:srgbClr val="F2F2F2"/>
+          </a:solidFill>
+          <a:ln>
+            <a:noFill/>
+          </a:ln>
+        </p:spPr>
+        <p:style>
+          <a:lnRef idx="1">
+            <a:schemeClr val="accent1"/>
+          </a:lnRef>
+          <a:fillRef idx="3">
+            <a:schemeClr val="accent1"/>
+          </a:fillRef>
+          <a:effectRef idx="2">
+            <a:schemeClr val="accent1"/>
+          </a:effectRef>
+          <a:fontRef idx="minor">
+            <a:schemeClr val="lt1"/>
+          </a:fontRef>
+        </p:style>
+        <p:txBody>
+          <a:bodyPr rtlCol="0" anchor="ctr"/>
+          <a:lstStyle/>
+          <a:p>
+            <a:pPr algn="ctr"/>
+          </a:p>
+        </p:txBody>
+      </p:sp>
+      <p:sp>
+        <p:nvSpPr>
+          <p:cNvPr id="10" name="TextBox 9"/>
+          <p:cNvSpPr txBox="1"/>
+          <p:nvPr/>
+        </p:nvSpPr>
+        <p:spPr>
+          <a:xfrm>
+            <a:off x="365760" y="2011680"/>
+            <a:ext cx="5212080" cy="365760"/>
+          </a:xfrm>
+          <a:prstGeom prst="rect">
+            <a:avLst/>
+          </a:prstGeom>
+          <a:noFill/>
+        </p:spPr>
+        <p:txBody>
+          <a:bodyPr wrap="square">
+            <a:spAutoFit/>
+          </a:bodyPr>
+          <a:lstStyle/>
+          <a:p>
+            <a:pPr algn="l"/>
+            <a:r>
+              <a:rPr sz="1200" b="1" i="0">
+                <a:solidFill>
+                  <a:srgbClr val="1F4E79"/>
+                </a:solidFill>
+                <a:latin typeface="맑은 고딕"/>
+              </a:rPr>
+              <a:t>FP = 12 개선 (오경보 줄이기)</a:t>
+            </a:r>
+          </a:p>
+        </p:txBody>
+      </p:sp>
+      <p:sp>
+        <p:nvSpPr>
+          <p:cNvPr id="11" name="TextBox 10"/>
+          <p:cNvSpPr txBox="1"/>
+          <p:nvPr/>
+        </p:nvSpPr>
+        <p:spPr>
+          <a:xfrm>
+            <a:off x="365760" y="2423160"/>
+            <a:ext cx="5212080" cy="3520440"/>
+          </a:xfrm>
+          <a:prstGeom prst="rect">
+            <a:avLst/>
+          </a:prstGeom>
+          <a:noFill/>
+        </p:spPr>
+        <p:txBody>
+          <a:bodyPr wrap="square">
+            <a:spAutoFit/>
+          </a:bodyPr>
+          <a:lstStyle/>
+          <a:p>
+            <a:pPr algn="l"/>
+            <a:r>
+              <a:rPr sz="1150" b="0" i="0">
+                <a:solidFill>
+                  <a:srgbClr val="1A1A1A"/>
+                </a:solidFill>
+                <a:latin typeface="맑은 고딕"/>
+              </a:rPr>
+              <a:t>① Threshold 상향 (0.50 → 0.65~0.75)
+   → 예측 확신도 높을 때만 고장 판정
+   → FP 감소, FN 증가 가능성
+② 정상 구간 말기 데이터 추가 수집
+   → 고장 초기와 구분되는 패턴 학습
+③ Class 0 가중치 소폭 증가
+   (class_weight={0:1.2, 1:1.0})
+⚠ 주의: FP를 줄이면 FN이 증가할 수 있음
+  → 제조업에서는 FN 최소화가 우선</a:t>
+            </a:r>
+          </a:p>
+        </p:txBody>
+      </p:sp>
+      <p:sp>
+        <p:nvSpPr>
+          <p:cNvPr id="12" name="Rectangle 11"/>
+          <p:cNvSpPr/>
+          <p:nvPr/>
+        </p:nvSpPr>
+        <p:spPr>
+          <a:xfrm>
+            <a:off x="5943600" y="1965960"/>
+            <a:ext cx="5943600" cy="4114800"/>
+          </a:xfrm>
+          <a:prstGeom prst="rect">
+            <a:avLst/>
+          </a:prstGeom>
+          <a:solidFill>
+            <a:srgbClr val="FFF3CD"/>
+          </a:solidFill>
+          <a:ln>
+            <a:noFill/>
+          </a:ln>
+        </p:spPr>
+        <p:style>
+          <a:lnRef idx="1">
+            <a:schemeClr val="accent1"/>
+          </a:lnRef>
+          <a:fillRef idx="3">
+            <a:schemeClr val="accent1"/>
+          </a:fillRef>
+          <a:effectRef idx="2">
+            <a:schemeClr val="accent1"/>
+          </a:effectRef>
+          <a:fontRef idx="minor">
+            <a:schemeClr val="lt1"/>
+          </a:fontRef>
+        </p:style>
+        <p:txBody>
+          <a:bodyPr rtlCol="0" anchor="ctr"/>
+          <a:lstStyle/>
+          <a:p>
+            <a:pPr algn="ctr"/>
+          </a:p>
+        </p:txBody>
+      </p:sp>
+      <p:sp>
+        <p:nvSpPr>
+          <p:cNvPr id="13" name="TextBox 12"/>
+          <p:cNvSpPr txBox="1"/>
+          <p:nvPr/>
+        </p:nvSpPr>
+        <p:spPr>
+          <a:xfrm>
+            <a:off x="6035040" y="2011680"/>
+            <a:ext cx="5760720" cy="365760"/>
+          </a:xfrm>
+          <a:prstGeom prst="rect">
+            <a:avLst/>
+          </a:prstGeom>
+          <a:noFill/>
+        </p:spPr>
+        <p:txBody>
+          <a:bodyPr wrap="square">
+            <a:spAutoFit/>
+          </a:bodyPr>
+          <a:lstStyle/>
+          <a:p>
+            <a:pPr algn="l"/>
+            <a:r>
+              <a:rPr sz="1200" b="1" i="0">
+                <a:solidFill>
+                  <a:srgbClr val="7B3600"/>
+                </a:solidFill>
+                <a:latin typeface="맑은 고딕"/>
+              </a:rPr>
+              <a:t>FN = 24 개선 ★ 우선순위 높음 (미감지 줄이기)</a:t>
+            </a:r>
+          </a:p>
+        </p:txBody>
+      </p:sp>
+      <p:sp>
+        <p:nvSpPr>
+          <p:cNvPr id="14" name="TextBox 13"/>
+          <p:cNvSpPr txBox="1"/>
+          <p:nvPr/>
+        </p:nvSpPr>
+        <p:spPr>
+          <a:xfrm>
+            <a:off x="6035040" y="2423160"/>
+            <a:ext cx="5760720" cy="3520440"/>
+          </a:xfrm>
+          <a:prstGeom prst="rect">
+            <a:avLst/>
+          </a:prstGeom>
+          <a:noFill/>
+        </p:spPr>
+        <p:txBody>
+          <a:bodyPr wrap="square">
+            <a:spAutoFit/>
+          </a:bodyPr>
+          <a:lstStyle/>
+          <a:p>
+            <a:pPr algn="l"/>
+            <a:r>
+              <a:rPr sz="1150" b="0" i="0">
+                <a:solidFill>
+                  <a:srgbClr val="1A1A1A"/>
+                </a:solidFill>
+                <a:latin typeface="맑은 고딕"/>
+              </a:rPr>
+              <a:t>① Threshold 하향 (0.50 → 0.30~0.40) ← 즉시 적용 가능
+   Streamlit 슬라이더로 현장에서 바로 조정
+   예상: Recall 0.68 → 0.80~0.85
+② Class 1 가중치 증가 (재학습 필요)
+   class_weight={0:1.0, 1:2.0~3.0}
+   → 학습 시 고장 샘플에 더 높은 손실 부과
+③ SMOTE 오버샘플링
+   Class 1(74건) 합성 샘플 추가
+   → 불균형 해소, 고장 패턴 학습 강화
+④ 피처 추가 (장기 개선)
+   진동 변화율, 주파수 도메인 특성</a:t>
+            </a:r>
+          </a:p>
+        </p:txBody>
+      </p:sp>
+      <p:sp>
+        <p:nvSpPr>
+          <p:cNvPr id="15" name="Rectangle 14"/>
+          <p:cNvSpPr/>
+          <p:nvPr/>
+        </p:nvSpPr>
+        <p:spPr>
+          <a:xfrm>
+            <a:off x="274320" y="6199632"/>
+            <a:ext cx="11612880" cy="274320"/>
+          </a:xfrm>
+          <a:prstGeom prst="rect">
+            <a:avLst/>
+          </a:prstGeom>
+          <a:solidFill>
+            <a:srgbClr val="1F4E79"/>
+          </a:solidFill>
+          <a:ln>
+            <a:noFill/>
+          </a:ln>
+        </p:spPr>
+        <p:style>
+          <a:lnRef idx="1">
+            <a:schemeClr val="accent1"/>
+          </a:lnRef>
+          <a:fillRef idx="3">
+            <a:schemeClr val="accent1"/>
+          </a:fillRef>
+          <a:effectRef idx="2">
+            <a:schemeClr val="accent1"/>
+          </a:effectRef>
+          <a:fontRef idx="minor">
+            <a:schemeClr val="lt1"/>
+          </a:fontRef>
+        </p:style>
+        <p:txBody>
+          <a:bodyPr rtlCol="0" anchor="ctr"/>
+          <a:lstStyle/>
+          <a:p>
+            <a:pPr algn="ctr"/>
+          </a:p>
+        </p:txBody>
+      </p:sp>
+      <p:sp>
+        <p:nvSpPr>
+          <p:cNvPr id="16" name="TextBox 15"/>
+          <p:cNvSpPr txBox="1"/>
+          <p:nvPr/>
+        </p:nvSpPr>
+        <p:spPr>
+          <a:xfrm>
+            <a:off x="365760" y="6217920"/>
+            <a:ext cx="11430000" cy="256032"/>
+          </a:xfrm>
+          <a:prstGeom prst="rect">
+            <a:avLst/>
+          </a:prstGeom>
+          <a:noFill/>
+        </p:spPr>
+        <p:txBody>
+          <a:bodyPr wrap="square">
+            <a:spAutoFit/>
+          </a:bodyPr>
+          <a:lstStyle/>
+          <a:p>
+            <a:pPr algn="ctr"/>
+            <a:r>
+              <a:rPr sz="1100" b="1" i="0">
+                <a:solidFill>
+                  <a:srgbClr val="FFFFFF"/>
+                </a:solidFill>
+                <a:latin typeface="맑은 고딕"/>
+              </a:rPr>
+              <a:t>1순위: Threshold 하향(슬라이더)  →  2순위: class_weight 재학습  →  3순위: SMOTE  →  4순위: 피처 엔지니어링 (Phase 2)</a:t>
+            </a:r>
+          </a:p>
+        </p:txBody>
+      </p:sp>
+    </p:spTree>
+  </p:cSld>
+  <p:clrMapOvr>
+    <a:masterClrMapping/>
+  </p:clrMapOvr>
+</p:sld>
+</file>
+
+<file path=ppt/slides/slide17.xml><?xml version="1.0" encoding="utf-8"?>
+<p:sld xmlns:a="http://schemas.openxmlformats.org/drawingml/2006/main" xmlns:p="http://schemas.openxmlformats.org/presentationml/2006/main" xmlns:r="http://schemas.openxmlformats.org/officeDocument/2006/relationships">
+  <p:cSld>
+    <p:spTree>
+      <p:nvGrpSpPr>
+        <p:cNvPr id="1" name=""/>
+        <p:cNvGrpSpPr/>
+        <p:nvPr/>
+      </p:nvGrpSpPr>
+      <p:grpSpPr/>
+      <p:sp>
+        <p:nvSpPr>
+          <p:cNvPr id="2" name="TextBox 1"/>
+          <p:cNvSpPr txBox="1"/>
+          <p:nvPr/>
+        </p:nvSpPr>
+        <p:spPr>
+          <a:xfrm>
+            <a:off x="457200" y="320040"/>
+            <a:ext cx="11274552" cy="594360"/>
+          </a:xfrm>
+          <a:prstGeom prst="rect">
+            <a:avLst/>
+          </a:prstGeom>
+          <a:noFill/>
+        </p:spPr>
+        <p:txBody>
+          <a:bodyPr wrap="none">
+            <a:spAutoFit/>
+          </a:bodyPr>
+          <a:lstStyle/>
+          <a:p>
+            <a:pPr algn="l"/>
+            <a:r>
+              <a:rPr sz="2200" b="1">
+                <a:solidFill>
+                  <a:srgbClr val="1F4E79"/>
+                </a:solidFill>
+              </a:rPr>
+              <a:t>부록 C. SHAP 예측 설명 분석 (로컬 CPU 1시간 이내)</a:t>
+            </a:r>
+          </a:p>
+        </p:txBody>
+      </p:sp>
+      <p:sp>
+        <p:nvSpPr>
+          <p:cNvPr id="3" name="TextBox 2"/>
+          <p:cNvSpPr txBox="1"/>
+          <p:nvPr/>
+        </p:nvSpPr>
+        <p:spPr>
+          <a:xfrm>
+            <a:off x="457200" y="1005840"/>
+            <a:ext cx="11274552" cy="1645920"/>
+          </a:xfrm>
+          <a:prstGeom prst="rect">
+            <a:avLst/>
+          </a:prstGeom>
+          <a:noFill/>
+        </p:spPr>
+        <p:txBody>
+          <a:bodyPr wrap="square">
+            <a:spAutoFit/>
+          </a:bodyPr>
+          <a:lstStyle/>
+          <a:p>
+            <a:r>
+              <a:rPr sz="1100">
+                <a:solidFill>
+                  <a:srgbClr val="333333"/>
+                </a:solidFill>
+              </a:rPr>
+              <a:t>[SHAP란?]
+게임이론 기반 피처 기여도 분해. 각 피처가 개별 예측에 얼마나 기여했는지 정량화.
+[적용 모델 및 방법]
+  1. 분류 모델 (LogisticRegression) - LinearExplainer : 선형 계수 기반 즉시 계산 (&lt;1초)
+  2. GRU v2 RUL 회귀 모델 - KernelExplainer (시간축 평균 근사) : 약 25초 (CPU)
+     * DeepExplainer/GradientExplainer는 Keras 커스텀 ops 미지원으로 KernelExplainer 폴백 사용
+[로컬 실행 방법]
+  pip install shap
+  python -m src.femto_shap
+  -&gt; 산출물/_imgs/S1_shap_clf.png, S2_shap_gru.png, S3_shap_bar.png 생성
+[해석 포인트]
+  Beeswarm: X축 = SHAP값 (+면 예측 증가, -면 예측 감소) | 색상 = 피처값 크기
+  막대: |SHAP| 평균 -&gt; 피처 전체 중요도 순위</a:t>
+            </a:r>
+          </a:p>
+        </p:txBody>
+      </p:sp>
+    </p:spTree>
+  </p:cSld>
+  <p:clrMapOvr>
+    <a:masterClrMapping/>
+  </p:clrMapOvr>
+</p:sld>
+</file>
+
+<file path=ppt/slides/slide18.xml><?xml version="1.0" encoding="utf-8"?>
+<p:sld xmlns:a="http://schemas.openxmlformats.org/drawingml/2006/main" xmlns:p="http://schemas.openxmlformats.org/presentationml/2006/main" xmlns:r="http://schemas.openxmlformats.org/officeDocument/2006/relationships">
+  <p:cSld>
+    <p:spTree>
+      <p:nvGrpSpPr>
+        <p:cNvPr id="1" name=""/>
+        <p:cNvGrpSpPr/>
+        <p:nvPr/>
+      </p:nvGrpSpPr>
+      <p:grpSpPr/>
+      <p:sp>
+        <p:nvSpPr>
+          <p:cNvPr id="2" name="TextBox 1"/>
+          <p:cNvSpPr txBox="1"/>
+          <p:nvPr/>
+        </p:nvSpPr>
+        <p:spPr>
+          <a:xfrm>
+            <a:off x="457200" y="320040"/>
+            <a:ext cx="11274552" cy="594360"/>
+          </a:xfrm>
+          <a:prstGeom prst="rect">
+            <a:avLst/>
+          </a:prstGeom>
+          <a:noFill/>
+        </p:spPr>
+        <p:txBody>
+          <a:bodyPr wrap="none">
+            <a:spAutoFit/>
+          </a:bodyPr>
+          <a:lstStyle/>
+          <a:p>
+            <a:pPr algn="l"/>
+            <a:r>
+              <a:rPr sz="2200" b="1">
+                <a:solidFill>
+                  <a:srgbClr val="1F4E79"/>
+                </a:solidFill>
+              </a:rPr>
+              <a:t>SHAP Beeswarm - 분류 모델 열화 감지 (LogisticRegression, Class1 기여도)</a:t>
+            </a:r>
+          </a:p>
+        </p:txBody>
+      </p:sp>
+      <p:pic>
+        <p:nvPicPr>
+          <p:cNvPr id="3" name="Picture 2" descr="S1_shap_clf.png"/>
+          <p:cNvPicPr>
+            <a:picLocks noChangeAspect="1"/>
+          </p:cNvPicPr>
+          <p:nvPr/>
+        </p:nvPicPr>
+        <p:blipFill>
+          <a:blip r:embed="rId2"/>
+          <a:stretch>
+            <a:fillRect/>
+          </a:stretch>
+        </p:blipFill>
+        <p:spPr>
+          <a:xfrm>
+            <a:off x="548640" y="914400"/>
+            <a:ext cx="7863840" cy="5189159"/>
+          </a:xfrm>
+          <a:prstGeom prst="rect">
+            <a:avLst/>
+          </a:prstGeom>
+        </p:spPr>
+      </p:pic>
+      <p:sp>
+        <p:nvSpPr>
+          <p:cNvPr id="4" name="TextBox 3"/>
+          <p:cNvSpPr txBox="1"/>
+          <p:nvPr/>
+        </p:nvSpPr>
+        <p:spPr>
+          <a:xfrm>
+            <a:off x="457200" y="5029200"/>
+            <a:ext cx="11274552" cy="1645920"/>
+          </a:xfrm>
+          <a:prstGeom prst="rect">
+            <a:avLst/>
+          </a:prstGeom>
+          <a:noFill/>
+        </p:spPr>
+        <p:txBody>
+          <a:bodyPr wrap="square">
+            <a:spAutoFit/>
+          </a:bodyPr>
+          <a:lstStyle/>
+          <a:p>
+            <a:r>
+              <a:rPr sz="1000">
+                <a:solidFill>
+                  <a:srgbClr val="333333"/>
+                </a:solidFill>
+              </a:rPr>
+              <a:t>[해석]
+  h_rms (수평 RMS): SHAP 절대값 최대 -&gt; 열화 감지 핵심 피처. 클수록 열화 확률 상승
+  h_kurt (첨도): 충격성 이상 반영. 높을수록 열화 확률 상승
+  rms_ratio (h/v 불균형): 방향성 이상 반영
+  temp_mean: 데이터 없어 0 처리 -&gt; 기여도 0 (온도 센서 미활용 환경)
+  결론: 수평 진동의 크기 + 충격성 조합이 열화 여부 결정에 지배적</a:t>
+            </a:r>
+          </a:p>
+        </p:txBody>
+      </p:sp>
+    </p:spTree>
+  </p:cSld>
+  <p:clrMapOvr>
+    <a:masterClrMapping/>
+  </p:clrMapOvr>
+</p:sld>
+</file>
+
+<file path=ppt/slides/slide19.xml><?xml version="1.0" encoding="utf-8"?>
+<p:sld xmlns:a="http://schemas.openxmlformats.org/drawingml/2006/main" xmlns:p="http://schemas.openxmlformats.org/presentationml/2006/main" xmlns:r="http://schemas.openxmlformats.org/officeDocument/2006/relationships">
+  <p:cSld>
+    <p:spTree>
+      <p:nvGrpSpPr>
+        <p:cNvPr id="1" name=""/>
+        <p:cNvGrpSpPr/>
+        <p:nvPr/>
+      </p:nvGrpSpPr>
+      <p:grpSpPr/>
+      <p:sp>
+        <p:nvSpPr>
+          <p:cNvPr id="2" name="TextBox 1"/>
+          <p:cNvSpPr txBox="1"/>
+          <p:nvPr/>
+        </p:nvSpPr>
+        <p:spPr>
+          <a:xfrm>
+            <a:off x="457200" y="320040"/>
+            <a:ext cx="11274552" cy="594360"/>
+          </a:xfrm>
+          <a:prstGeom prst="rect">
+            <a:avLst/>
+          </a:prstGeom>
+          <a:noFill/>
+        </p:spPr>
+        <p:txBody>
+          <a:bodyPr wrap="none">
+            <a:spAutoFit/>
+          </a:bodyPr>
+          <a:lstStyle/>
+          <a:p>
+            <a:pPr algn="l"/>
+            <a:r>
+              <a:rPr sz="2200" b="1">
+                <a:solidFill>
+                  <a:srgbClr val="1F4E79"/>
+                </a:solidFill>
+              </a:rPr>
+              <a:t>SHAP - GRU v2 RUL 예측 (왼쪽) &amp; 두 모델 피처 중요도 비교 (오른쪽)</a:t>
+            </a:r>
+          </a:p>
+        </p:txBody>
+      </p:sp>
+      <p:pic>
+        <p:nvPicPr>
+          <p:cNvPr id="3" name="Picture 2" descr="S2_shap_gru.png"/>
+          <p:cNvPicPr>
+            <a:picLocks noChangeAspect="1"/>
+          </p:cNvPicPr>
+          <p:nvPr/>
+        </p:nvPicPr>
+        <p:blipFill>
+          <a:blip r:embed="rId2"/>
+          <a:stretch>
+            <a:fillRect/>
+          </a:stretch>
+        </p:blipFill>
+        <p:spPr>
+          <a:xfrm>
+            <a:off x="274320" y="914400"/>
+            <a:ext cx="4206240" cy="2786727"/>
+          </a:xfrm>
+          <a:prstGeom prst="rect">
+            <a:avLst/>
+          </a:prstGeom>
+        </p:spPr>
+      </p:pic>
+      <p:pic>
+        <p:nvPicPr>
+          <p:cNvPr id="4" name="Picture 3" descr="S3_shap_bar.png"/>
+          <p:cNvPicPr>
+            <a:picLocks noChangeAspect="1"/>
+          </p:cNvPicPr>
+          <p:nvPr/>
+        </p:nvPicPr>
+        <p:blipFill>
+          <a:blip r:embed="rId3"/>
+          <a:stretch>
+            <a:fillRect/>
+          </a:stretch>
+        </p:blipFill>
+        <p:spPr>
+          <a:xfrm>
+            <a:off x="4663440" y="914400"/>
+            <a:ext cx="4297680" cy="1611630"/>
+          </a:xfrm>
+          <a:prstGeom prst="rect">
+            <a:avLst/>
+          </a:prstGeom>
+        </p:spPr>
+      </p:pic>
+      <p:sp>
+        <p:nvSpPr>
+          <p:cNvPr id="5" name="TextBox 4"/>
+          <p:cNvSpPr txBox="1"/>
+          <p:nvPr/>
+        </p:nvSpPr>
+        <p:spPr>
+          <a:xfrm>
+            <a:off x="457200" y="5120640"/>
+            <a:ext cx="11274552" cy="1645920"/>
+          </a:xfrm>
+          <a:prstGeom prst="rect">
+            <a:avLst/>
+          </a:prstGeom>
+          <a:noFill/>
+        </p:spPr>
+        <p:txBody>
+          <a:bodyPr wrap="square">
+            <a:spAutoFit/>
+          </a:bodyPr>
+          <a:lstStyle/>
+          <a:p>
+            <a:r>
+              <a:rPr sz="1000">
+                <a:solidFill>
+                  <a:srgbClr val="333333"/>
+                </a:solidFill>
+              </a:rPr>
+              <a:t>[GRU RUL 모델 - 왼쪽]
+  energy (총 진동 에너지) + h_rms 가 RUL 예측에 최대 기여 | 에너지 높을수록 잔여수명 단축(RUL-)
+[두 모델 비교 - 오른쪽]
+  분류(열화감지): h_rms &gt; h_kurt &gt; rms_ratio 순
+  GRU(RUL회귀):  energy &gt; h_rms &gt; health_idx 순
+  -&gt; energy 파생 피처가 RUL 회귀에서 추가 변별력 제공 / 두 모델 모두 h_rms 핵심</a:t>
             </a:r>
           </a:p>
         </p:txBody>

</xml_diff>

<commit_message>
feat: DL Streamlit 탭4 리뉴얼 + PPT/Word 산출물 최신화
Streamlit (app/streamlit_femto.py):
- 탭1 이름에 '(demo data loading)' 추가
- 탭4 '통합 진단': ML+DL 2단 진단 비교 expander 추가
- 탭4 서브탭 추가 — CSV 일괄 진단(FEMTO CSV 업로드 → ML+DL 배치 예측, 결과 다운로드)
- Streamlit Cloud 빨간 에러 수정: @st.cache_data 빈 DataFrame 캐시 버그 fix
- 홈에 ML 앱(mlfactoryautomation.streamlit.app) 링크 버튼 추가

PPT (딥러닝_FEMTO_RUL_발표자료.pptx) 21장:
- 슬라이드 12 신규: ML+DL 통합으로 PdM 고장예지 범위 확장 (결론 확장)
- 슬라이드 17 신규: SHAP 핵심 인사이트 (S3 bar chart + 3가지 key finding)

Word (딥러닝_산출물_20260625_FEMTO_RUL_발표용.docx):
- 부록 E.4 SHAP 분석 (fallback 설명, 장단점 표)
- 부록 F RAG Level 1/2 시스템 (FAISS + cosine + weighted RUL)
</commit_message>
<xml_diff>
--- a/Homework/DL_FactoryAutomation/산출물/딥러닝_FEMTO_RUL_발표자료.pptx
+++ b/Homework/DL_FactoryAutomation/산출물/딥러닝_FEMTO_RUL_발표자료.pptx
@@ -17,10 +17,12 @@
     <p:sldId id="265" r:id="rId16"/>
     <p:sldId id="266" r:id="rId17"/>
     <p:sldId id="267" r:id="rId18"/>
+    <p:sldId id="275" r:id="rId26"/>
     <p:sldId id="268" r:id="rId19"/>
     <p:sldId id="269" r:id="rId20"/>
     <p:sldId id="270" r:id="rId21"/>
     <p:sldId id="271" r:id="rId22"/>
+    <p:sldId id="276" r:id="rId27"/>
     <p:sldId id="272" r:id="rId23"/>
     <p:sldId id="273" r:id="rId24"/>
     <p:sldId id="274" r:id="rId25"/>
@@ -7722,6 +7724,242 @@
       <p:grpSpPr/>
       <p:sp>
         <p:nvSpPr>
+          <p:cNvPr id="2" name="TextBox 1"/>
+          <p:cNvSpPr txBox="1"/>
+          <p:nvPr/>
+        </p:nvSpPr>
+        <p:spPr>
+          <a:xfrm>
+            <a:off x="274320" y="91440"/>
+            <a:ext cx="11640312" cy="548640"/>
+          </a:xfrm>
+          <a:prstGeom prst="rect">
+            <a:avLst/>
+          </a:prstGeom>
+          <a:noFill/>
+        </p:spPr>
+        <p:txBody>
+          <a:bodyPr wrap="square">
+            <a:spAutoFit/>
+          </a:bodyPr>
+          <a:lstStyle/>
+          <a:p>
+            <a:pPr algn="l"/>
+            <a:r>
+              <a:rPr sz="1900" b="1">
+                <a:solidFill>
+                  <a:srgbClr val="1F4E79"/>
+                </a:solidFill>
+              </a:rPr>
+              <a:t>II-6 추가. ML+DL 통합으로 PdM 고장예지 범위 확장</a:t>
+            </a:r>
+          </a:p>
+        </p:txBody>
+      </p:sp>
+      <p:sp>
+        <p:nvSpPr>
+          <p:cNvPr id="3" name="TextBox 2"/>
+          <p:cNvSpPr txBox="1"/>
+          <p:nvPr/>
+        </p:nvSpPr>
+        <p:spPr>
+          <a:xfrm>
+            <a:off x="274320" y="658368"/>
+            <a:ext cx="11640312" cy="320040"/>
+          </a:xfrm>
+          <a:prstGeom prst="rect">
+            <a:avLst/>
+          </a:prstGeom>
+          <a:noFill/>
+        </p:spPr>
+        <p:txBody>
+          <a:bodyPr wrap="square">
+            <a:spAutoFit/>
+          </a:bodyPr>
+          <a:lstStyle/>
+          <a:p>
+            <a:pPr algn="l"/>
+            <a:r>
+              <a:rPr sz="1300" b="1">
+                <a:solidFill>
+                  <a:srgbClr val="2E75B6"/>
+                </a:solidFill>
+              </a:rPr>
+              <a:t>1. 이 DL 시스템 내 ML+DL 2단 진단 효과</a:t>
+            </a:r>
+          </a:p>
+        </p:txBody>
+      </p:sp>
+      <p:sp>
+        <p:nvSpPr>
+          <p:cNvPr id="4" name="TextBox 3"/>
+          <p:cNvSpPr txBox="1"/>
+          <p:nvPr/>
+        </p:nvSpPr>
+        <p:spPr>
+          <a:xfrm>
+            <a:off x="320040" y="1005840"/>
+            <a:ext cx="11548872" cy="1371600"/>
+          </a:xfrm>
+          <a:prstGeom prst="rect">
+            <a:avLst/>
+          </a:prstGeom>
+          <a:noFill/>
+        </p:spPr>
+        <p:txBody>
+          <a:bodyPr wrap="square">
+            <a:spAutoFit/>
+          </a:bodyPr>
+          <a:lstStyle/>
+          <a:p>
+            <a:pPr algn="l"/>
+            <a:r>
+              <a:rPr sz="1050" b="0">
+                <a:solidFill>
+                  <a:srgbClr val="1A1A1A"/>
+                </a:solidFill>
+              </a:rPr>
+              <a:t>  ML (LogReg) : 이진 알람 - 지금 열화 중인가?  (빠름, 경량, 설명 가능)
+  DL (LSTM)   : 정량 예측 - 잔여수명 몇 분?    (시계열 패턴 학습)
+  결합 효과   : 열화 감지 -&gt; RUL 정량화 -&gt; 경보  (오경보 DOWN, 정보량 UP)
+  ML만 있을 때  : '고장 가능성 있음'
+  ML+DL 결합   : '열화 감지됨 + 잔여수명 약 47분 -&gt; 다음 교대조 전 교체 권장'</a:t>
+            </a:r>
+          </a:p>
+        </p:txBody>
+      </p:sp>
+      <p:sp>
+        <p:nvSpPr>
+          <p:cNvPr id="5" name="TextBox 4"/>
+          <p:cNvSpPr txBox="1"/>
+          <p:nvPr/>
+        </p:nvSpPr>
+        <p:spPr>
+          <a:xfrm>
+            <a:off x="274320" y="2423160"/>
+            <a:ext cx="11640312" cy="320040"/>
+          </a:xfrm>
+          <a:prstGeom prst="rect">
+            <a:avLst/>
+          </a:prstGeom>
+          <a:noFill/>
+        </p:spPr>
+        <p:txBody>
+          <a:bodyPr wrap="square">
+            <a:spAutoFit/>
+          </a:bodyPr>
+          <a:lstStyle/>
+          <a:p>
+            <a:pPr algn="l"/>
+            <a:r>
+              <a:rPr sz="1300" b="1">
+                <a:solidFill>
+                  <a:srgbClr val="2E75B6"/>
+                </a:solidFill>
+              </a:rPr>
+              <a:t>2. ML 과제 + DL 과제 통합 시 PdM 커버리지 확장</a:t>
+            </a:r>
+          </a:p>
+        </p:txBody>
+      </p:sp>
+      <p:sp>
+        <p:nvSpPr>
+          <p:cNvPr id="6" name="TextBox 5"/>
+          <p:cNvSpPr txBox="1"/>
+          <p:nvPr/>
+        </p:nvSpPr>
+        <p:spPr>
+          <a:xfrm>
+            <a:off x="320040" y="2788920"/>
+            <a:ext cx="11548872" cy="2606040"/>
+          </a:xfrm>
+          <a:prstGeom prst="rect">
+            <a:avLst/>
+          </a:prstGeom>
+          <a:noFill/>
+        </p:spPr>
+        <p:txBody>
+          <a:bodyPr wrap="square">
+            <a:spAutoFit/>
+          </a:bodyPr>
+          <a:lstStyle/>
+          <a:p>
+            <a:pPr algn="l"/>
+            <a:r>
+              <a:rPr sz="1050" b="0">
+                <a:solidFill>
+                  <a:srgbClr val="1A1A1A"/>
+                </a:solidFill>
+              </a:rPr>
+              <a:t>  ML 과제 (mlfactoryautomation.streamlit.app)
+    대상: CNC 공작기계 (선삭/밀링)
+    고장: 공구마모, 열발산, 전력과부하, 오버스트레인, 무작위 고장 5종
+    방법: 랜덤포레스트/XGBoost 이진 분류
+  DL 과제 (이 앱 - dlfactoryautomation.streamlit.app)
+    대상: 회전기계 베어링 (FEMTO-ST IEEE PHM 2012)
+    고장: 피로균열, 표면마모 등 진동 기반 열화
+    방법: ML(열화 분류) + LSTM(잔여수명 예측) 2단 진단
+  두 시스템 통합
+    가공 장비(CNC) + 회전체(베어링) = 제조 라인 전체 PdM 커버
+    장비 유형별 전문 모델 -&gt; 스마트 팩토리 예지보전 플랫폼 완성</a:t>
+            </a:r>
+          </a:p>
+        </p:txBody>
+      </p:sp>
+      <p:sp>
+        <p:nvSpPr>
+          <p:cNvPr id="7" name="TextBox 6"/>
+          <p:cNvSpPr txBox="1"/>
+          <p:nvPr/>
+        </p:nvSpPr>
+        <p:spPr>
+          <a:xfrm>
+            <a:off x="274320" y="5532120"/>
+            <a:ext cx="11640312" cy="822960"/>
+          </a:xfrm>
+          <a:prstGeom prst="rect">
+            <a:avLst/>
+          </a:prstGeom>
+          <a:noFill/>
+        </p:spPr>
+        <p:txBody>
+          <a:bodyPr wrap="square">
+            <a:spAutoFit/>
+          </a:bodyPr>
+          <a:lstStyle/>
+          <a:p>
+            <a:pPr algn="l"/>
+            <a:r>
+              <a:rPr sz="1050" b="0">
+                <a:solidFill>
+                  <a:srgbClr val="C00000"/>
+                </a:solidFill>
+              </a:rPr>
+              <a:t>결론: 두 시스템을 함께 운영하면 '가공 장비 고장'과 '베어링 마모'를 모두 사전에 감지하고 정량화할 수 있어, PdM 예지보전 대상 범위와 예측 정밀도가 동시에 향상됩니다.</a:t>
+            </a:r>
+          </a:p>
+        </p:txBody>
+      </p:sp>
+    </p:spTree>
+  </p:cSld>
+  <p:clrMapOvr>
+    <a:masterClrMapping/>
+  </p:clrMapOvr>
+</p:sld>
+</file>
+
+<file path=ppt/slides/slide14.xml><?xml version="1.0" encoding="utf-8"?>
+<p:sld xmlns:a="http://schemas.openxmlformats.org/drawingml/2006/main" xmlns:p="http://schemas.openxmlformats.org/presentationml/2006/main" xmlns:r="http://schemas.openxmlformats.org/officeDocument/2006/relationships">
+  <p:cSld>
+    <p:spTree>
+      <p:nvGrpSpPr>
+        <p:cNvPr id="1" name=""/>
+        <p:cNvGrpSpPr/>
+        <p:nvPr/>
+      </p:nvGrpSpPr>
+      <p:grpSpPr/>
+      <p:sp>
+        <p:nvSpPr>
           <p:cNvPr id="2" name="Rectangle 1"/>
           <p:cNvSpPr/>
           <p:nvPr/>
@@ -9587,7 +9825,7 @@
 </p:sld>
 </file>
 
-<file path=ppt/slides/slide14.xml><?xml version="1.0" encoding="utf-8"?>
+<file path=ppt/slides/slide15.xml><?xml version="1.0" encoding="utf-8"?>
 <p:sld xmlns:a="http://schemas.openxmlformats.org/drawingml/2006/main" xmlns:p="http://schemas.openxmlformats.org/presentationml/2006/main" xmlns:r="http://schemas.openxmlformats.org/officeDocument/2006/relationships">
   <p:cSld>
     <p:spTree>
@@ -11062,7 +11300,7 @@
 </p:sld>
 </file>
 
-<file path=ppt/slides/slide15.xml><?xml version="1.0" encoding="utf-8"?>
+<file path=ppt/slides/slide16.xml><?xml version="1.0" encoding="utf-8"?>
 <p:sld xmlns:a="http://schemas.openxmlformats.org/drawingml/2006/main" xmlns:p="http://schemas.openxmlformats.org/presentationml/2006/main" xmlns:r="http://schemas.openxmlformats.org/officeDocument/2006/relationships">
   <p:cSld>
     <p:spTree>
@@ -11939,615 +12177,6 @@
 • FN 24건: 실제 고장 미감지 → 설비 손상·라인 정지 위험 ★
 • Class 1 Recall 0.68 → 고장 32% 놓침 → 개선 필요
 • Threshold 0.50→0.35 하향 시 FN 대폭 감소 가능</a:t>
-            </a:r>
-          </a:p>
-        </p:txBody>
-      </p:sp>
-    </p:spTree>
-  </p:cSld>
-  <p:clrMapOvr>
-    <a:masterClrMapping/>
-  </p:clrMapOvr>
-</p:sld>
-</file>
-
-<file path=ppt/slides/slide16.xml><?xml version="1.0" encoding="utf-8"?>
-<p:sld xmlns:a="http://schemas.openxmlformats.org/drawingml/2006/main" xmlns:p="http://schemas.openxmlformats.org/presentationml/2006/main" xmlns:r="http://schemas.openxmlformats.org/officeDocument/2006/relationships">
-  <p:cSld>
-    <p:spTree>
-      <p:nvGrpSpPr>
-        <p:cNvPr id="1" name=""/>
-        <p:cNvGrpSpPr/>
-        <p:nvPr/>
-      </p:nvGrpSpPr>
-      <p:grpSpPr/>
-      <p:sp>
-        <p:nvSpPr>
-          <p:cNvPr id="2" name="Rectangle 1"/>
-          <p:cNvSpPr/>
-          <p:nvPr/>
-        </p:nvSpPr>
-        <p:spPr>
-          <a:xfrm>
-            <a:off x="0" y="0"/>
-            <a:ext cx="12188952" cy="960120"/>
-          </a:xfrm>
-          <a:prstGeom prst="rect">
-            <a:avLst/>
-          </a:prstGeom>
-          <a:solidFill>
-            <a:srgbClr val="1F4E79"/>
-          </a:solidFill>
-          <a:ln>
-            <a:noFill/>
-          </a:ln>
-        </p:spPr>
-        <p:style>
-          <a:lnRef idx="1">
-            <a:schemeClr val="accent1"/>
-          </a:lnRef>
-          <a:fillRef idx="3">
-            <a:schemeClr val="accent1"/>
-          </a:fillRef>
-          <a:effectRef idx="2">
-            <a:schemeClr val="accent1"/>
-          </a:effectRef>
-          <a:fontRef idx="minor">
-            <a:schemeClr val="lt1"/>
-          </a:fontRef>
-        </p:style>
-        <p:txBody>
-          <a:bodyPr rtlCol="0" anchor="ctr"/>
-          <a:lstStyle/>
-          <a:p>
-            <a:pPr algn="ctr"/>
-          </a:p>
-        </p:txBody>
-      </p:sp>
-      <p:sp>
-        <p:nvSpPr>
-          <p:cNvPr id="3" name="Rectangle 2"/>
-          <p:cNvSpPr/>
-          <p:nvPr/>
-        </p:nvSpPr>
-        <p:spPr>
-          <a:xfrm>
-            <a:off x="0" y="6784848"/>
-            <a:ext cx="12188952" cy="73152"/>
-          </a:xfrm>
-          <a:prstGeom prst="rect">
-            <a:avLst/>
-          </a:prstGeom>
-          <a:solidFill>
-            <a:srgbClr val="2E75B6"/>
-          </a:solidFill>
-          <a:ln>
-            <a:noFill/>
-          </a:ln>
-        </p:spPr>
-        <p:style>
-          <a:lnRef idx="1">
-            <a:schemeClr val="accent1"/>
-          </a:lnRef>
-          <a:fillRef idx="3">
-            <a:schemeClr val="accent1"/>
-          </a:fillRef>
-          <a:effectRef idx="2">
-            <a:schemeClr val="accent1"/>
-          </a:effectRef>
-          <a:fontRef idx="minor">
-            <a:schemeClr val="lt1"/>
-          </a:fontRef>
-        </p:style>
-        <p:txBody>
-          <a:bodyPr rtlCol="0" anchor="ctr"/>
-          <a:lstStyle/>
-          <a:p>
-            <a:pPr algn="ctr"/>
-          </a:p>
-        </p:txBody>
-      </p:sp>
-      <p:sp>
-        <p:nvSpPr>
-          <p:cNvPr id="4" name="TextBox 3"/>
-          <p:cNvSpPr txBox="1"/>
-          <p:nvPr/>
-        </p:nvSpPr>
-        <p:spPr>
-          <a:xfrm>
-            <a:off x="274320" y="54864"/>
-            <a:ext cx="10058400" cy="594360"/>
-          </a:xfrm>
-          <a:prstGeom prst="rect">
-            <a:avLst/>
-          </a:prstGeom>
-          <a:noFill/>
-        </p:spPr>
-        <p:txBody>
-          <a:bodyPr wrap="square">
-            <a:spAutoFit/>
-          </a:bodyPr>
-          <a:lstStyle/>
-          <a:p>
-            <a:pPr algn="l"/>
-            <a:r>
-              <a:rPr sz="2600" b="1" i="0">
-                <a:solidFill>
-                  <a:srgbClr val="FFFFFF"/>
-                </a:solidFill>
-                <a:latin typeface="맑은 고딕"/>
-              </a:rPr>
-              <a:t>FP / FN 개선 방향 분석</a:t>
-            </a:r>
-          </a:p>
-        </p:txBody>
-      </p:sp>
-      <p:sp>
-        <p:nvSpPr>
-          <p:cNvPr id="5" name="TextBox 4"/>
-          <p:cNvSpPr txBox="1"/>
-          <p:nvPr/>
-        </p:nvSpPr>
-        <p:spPr>
-          <a:xfrm>
-            <a:off x="320040" y="621792"/>
-            <a:ext cx="11430000" cy="320040"/>
-          </a:xfrm>
-          <a:prstGeom prst="rect">
-            <a:avLst/>
-          </a:prstGeom>
-          <a:noFill/>
-        </p:spPr>
-        <p:txBody>
-          <a:bodyPr wrap="square">
-            <a:spAutoFit/>
-          </a:bodyPr>
-          <a:lstStyle/>
-          <a:p>
-            <a:pPr algn="l"/>
-            <a:r>
-              <a:rPr sz="1200" b="0" i="1">
-                <a:solidFill>
-                  <a:srgbClr val="BDD7EE"/>
-                </a:solidFill>
-                <a:latin typeface="맑은 고딕"/>
-              </a:rPr>
-              <a:t>False Positive(오경보) vs False Negative(미감지)  ·  우선순위 기반 개선 로드맵</a:t>
-            </a:r>
-          </a:p>
-        </p:txBody>
-      </p:sp>
-      <p:sp>
-        <p:nvSpPr>
-          <p:cNvPr id="6" name="Rectangle 5"/>
-          <p:cNvSpPr/>
-          <p:nvPr/>
-        </p:nvSpPr>
-        <p:spPr>
-          <a:xfrm>
-            <a:off x="274320" y="1051560"/>
-            <a:ext cx="11612880" cy="777240"/>
-          </a:xfrm>
-          <a:prstGeom prst="rect">
-            <a:avLst/>
-          </a:prstGeom>
-          <a:solidFill>
-            <a:srgbClr val="D6E4F7"/>
-          </a:solidFill>
-          <a:ln>
-            <a:noFill/>
-          </a:ln>
-        </p:spPr>
-        <p:style>
-          <a:lnRef idx="1">
-            <a:schemeClr val="accent1"/>
-          </a:lnRef>
-          <a:fillRef idx="3">
-            <a:schemeClr val="accent1"/>
-          </a:fillRef>
-          <a:effectRef idx="2">
-            <a:schemeClr val="accent1"/>
-          </a:effectRef>
-          <a:fontRef idx="minor">
-            <a:schemeClr val="lt1"/>
-          </a:fontRef>
-        </p:style>
-        <p:txBody>
-          <a:bodyPr rtlCol="0" anchor="ctr"/>
-          <a:lstStyle/>
-          <a:p>
-            <a:pPr algn="ctr"/>
-          </a:p>
-        </p:txBody>
-      </p:sp>
-      <p:sp>
-        <p:nvSpPr>
-          <p:cNvPr id="7" name="TextBox 6"/>
-          <p:cNvSpPr txBox="1"/>
-          <p:nvPr/>
-        </p:nvSpPr>
-        <p:spPr>
-          <a:xfrm>
-            <a:off x="365760" y="1078992"/>
-            <a:ext cx="11430000" cy="347472"/>
-          </a:xfrm>
-          <a:prstGeom prst="rect">
-            <a:avLst/>
-          </a:prstGeom>
-          <a:noFill/>
-        </p:spPr>
-        <p:txBody>
-          <a:bodyPr wrap="square">
-            <a:spAutoFit/>
-          </a:bodyPr>
-          <a:lstStyle/>
-          <a:p>
-            <a:pPr algn="l"/>
-            <a:r>
-              <a:rPr sz="1300" b="1" i="0">
-                <a:solidFill>
-                  <a:srgbClr val="1F4E79"/>
-                </a:solidFill>
-                <a:latin typeface="맑은 고딕"/>
-              </a:rPr>
-              <a:t>오경보(FP) vs 미감지(FN) — 제조업 관점</a:t>
-            </a:r>
-          </a:p>
-        </p:txBody>
-      </p:sp>
-      <p:sp>
-        <p:nvSpPr>
-          <p:cNvPr id="8" name="TextBox 7"/>
-          <p:cNvSpPr txBox="1"/>
-          <p:nvPr/>
-        </p:nvSpPr>
-        <p:spPr>
-          <a:xfrm>
-            <a:off x="365760" y="1435608"/>
-            <a:ext cx="11430000" cy="347472"/>
-          </a:xfrm>
-          <a:prstGeom prst="rect">
-            <a:avLst/>
-          </a:prstGeom>
-          <a:noFill/>
-        </p:spPr>
-        <p:txBody>
-          <a:bodyPr wrap="square">
-            <a:spAutoFit/>
-          </a:bodyPr>
-          <a:lstStyle/>
-          <a:p>
-            <a:pPr algn="l"/>
-            <a:r>
-              <a:rPr sz="1150" b="0" i="0">
-                <a:solidFill>
-                  <a:srgbClr val="1A1A1A"/>
-                </a:solidFill>
-                <a:latin typeface="맑은 고딕"/>
-              </a:rPr>
-              <a:t>FP(오경보): 안전 측면 위험 없음, 불필요한 유지보수 비용 발생  |  FN(미감지): 실제 고장 방치 → 설비 파손·생산 중단 → 비용/안전 모두 위험 ★★★</a:t>
-            </a:r>
-          </a:p>
-        </p:txBody>
-      </p:sp>
-      <p:sp>
-        <p:nvSpPr>
-          <p:cNvPr id="9" name="Rectangle 8"/>
-          <p:cNvSpPr/>
-          <p:nvPr/>
-        </p:nvSpPr>
-        <p:spPr>
-          <a:xfrm>
-            <a:off x="274320" y="1965960"/>
-            <a:ext cx="5394960" cy="4114800"/>
-          </a:xfrm>
-          <a:prstGeom prst="rect">
-            <a:avLst/>
-          </a:prstGeom>
-          <a:solidFill>
-            <a:srgbClr val="F2F2F2"/>
-          </a:solidFill>
-          <a:ln>
-            <a:noFill/>
-          </a:ln>
-        </p:spPr>
-        <p:style>
-          <a:lnRef idx="1">
-            <a:schemeClr val="accent1"/>
-          </a:lnRef>
-          <a:fillRef idx="3">
-            <a:schemeClr val="accent1"/>
-          </a:fillRef>
-          <a:effectRef idx="2">
-            <a:schemeClr val="accent1"/>
-          </a:effectRef>
-          <a:fontRef idx="minor">
-            <a:schemeClr val="lt1"/>
-          </a:fontRef>
-        </p:style>
-        <p:txBody>
-          <a:bodyPr rtlCol="0" anchor="ctr"/>
-          <a:lstStyle/>
-          <a:p>
-            <a:pPr algn="ctr"/>
-          </a:p>
-        </p:txBody>
-      </p:sp>
-      <p:sp>
-        <p:nvSpPr>
-          <p:cNvPr id="10" name="TextBox 9"/>
-          <p:cNvSpPr txBox="1"/>
-          <p:nvPr/>
-        </p:nvSpPr>
-        <p:spPr>
-          <a:xfrm>
-            <a:off x="365760" y="2011680"/>
-            <a:ext cx="5212080" cy="365760"/>
-          </a:xfrm>
-          <a:prstGeom prst="rect">
-            <a:avLst/>
-          </a:prstGeom>
-          <a:noFill/>
-        </p:spPr>
-        <p:txBody>
-          <a:bodyPr wrap="square">
-            <a:spAutoFit/>
-          </a:bodyPr>
-          <a:lstStyle/>
-          <a:p>
-            <a:pPr algn="l"/>
-            <a:r>
-              <a:rPr sz="1200" b="1" i="0">
-                <a:solidFill>
-                  <a:srgbClr val="1F4E79"/>
-                </a:solidFill>
-                <a:latin typeface="맑은 고딕"/>
-              </a:rPr>
-              <a:t>FP = 12 개선 (오경보 줄이기)</a:t>
-            </a:r>
-          </a:p>
-        </p:txBody>
-      </p:sp>
-      <p:sp>
-        <p:nvSpPr>
-          <p:cNvPr id="11" name="TextBox 10"/>
-          <p:cNvSpPr txBox="1"/>
-          <p:nvPr/>
-        </p:nvSpPr>
-        <p:spPr>
-          <a:xfrm>
-            <a:off x="365760" y="2423160"/>
-            <a:ext cx="5212080" cy="3520440"/>
-          </a:xfrm>
-          <a:prstGeom prst="rect">
-            <a:avLst/>
-          </a:prstGeom>
-          <a:noFill/>
-        </p:spPr>
-        <p:txBody>
-          <a:bodyPr wrap="square">
-            <a:spAutoFit/>
-          </a:bodyPr>
-          <a:lstStyle/>
-          <a:p>
-            <a:pPr algn="l"/>
-            <a:r>
-              <a:rPr sz="1150" b="0" i="0">
-                <a:solidFill>
-                  <a:srgbClr val="1A1A1A"/>
-                </a:solidFill>
-                <a:latin typeface="맑은 고딕"/>
-              </a:rPr>
-              <a:t>① Threshold 상향 (0.50 → 0.65~0.75)
-   → 예측 확신도 높을 때만 고장 판정
-   → FP 감소, FN 증가 가능성
-② 정상 구간 말기 데이터 추가 수집
-   → 고장 초기와 구분되는 패턴 학습
-③ Class 0 가중치 소폭 증가
-   (class_weight={0:1.2, 1:1.0})
-⚠ 주의: FP를 줄이면 FN이 증가할 수 있음
-  → 제조업에서는 FN 최소화가 우선</a:t>
-            </a:r>
-          </a:p>
-        </p:txBody>
-      </p:sp>
-      <p:sp>
-        <p:nvSpPr>
-          <p:cNvPr id="12" name="Rectangle 11"/>
-          <p:cNvSpPr/>
-          <p:nvPr/>
-        </p:nvSpPr>
-        <p:spPr>
-          <a:xfrm>
-            <a:off x="5943600" y="1965960"/>
-            <a:ext cx="5943600" cy="4114800"/>
-          </a:xfrm>
-          <a:prstGeom prst="rect">
-            <a:avLst/>
-          </a:prstGeom>
-          <a:solidFill>
-            <a:srgbClr val="FFF3CD"/>
-          </a:solidFill>
-          <a:ln>
-            <a:noFill/>
-          </a:ln>
-        </p:spPr>
-        <p:style>
-          <a:lnRef idx="1">
-            <a:schemeClr val="accent1"/>
-          </a:lnRef>
-          <a:fillRef idx="3">
-            <a:schemeClr val="accent1"/>
-          </a:fillRef>
-          <a:effectRef idx="2">
-            <a:schemeClr val="accent1"/>
-          </a:effectRef>
-          <a:fontRef idx="minor">
-            <a:schemeClr val="lt1"/>
-          </a:fontRef>
-        </p:style>
-        <p:txBody>
-          <a:bodyPr rtlCol="0" anchor="ctr"/>
-          <a:lstStyle/>
-          <a:p>
-            <a:pPr algn="ctr"/>
-          </a:p>
-        </p:txBody>
-      </p:sp>
-      <p:sp>
-        <p:nvSpPr>
-          <p:cNvPr id="13" name="TextBox 12"/>
-          <p:cNvSpPr txBox="1"/>
-          <p:nvPr/>
-        </p:nvSpPr>
-        <p:spPr>
-          <a:xfrm>
-            <a:off x="6035040" y="2011680"/>
-            <a:ext cx="5760720" cy="365760"/>
-          </a:xfrm>
-          <a:prstGeom prst="rect">
-            <a:avLst/>
-          </a:prstGeom>
-          <a:noFill/>
-        </p:spPr>
-        <p:txBody>
-          <a:bodyPr wrap="square">
-            <a:spAutoFit/>
-          </a:bodyPr>
-          <a:lstStyle/>
-          <a:p>
-            <a:pPr algn="l"/>
-            <a:r>
-              <a:rPr sz="1200" b="1" i="0">
-                <a:solidFill>
-                  <a:srgbClr val="7B3600"/>
-                </a:solidFill>
-                <a:latin typeface="맑은 고딕"/>
-              </a:rPr>
-              <a:t>FN = 24 개선 ★ 우선순위 높음 (미감지 줄이기)</a:t>
-            </a:r>
-          </a:p>
-        </p:txBody>
-      </p:sp>
-      <p:sp>
-        <p:nvSpPr>
-          <p:cNvPr id="14" name="TextBox 13"/>
-          <p:cNvSpPr txBox="1"/>
-          <p:nvPr/>
-        </p:nvSpPr>
-        <p:spPr>
-          <a:xfrm>
-            <a:off x="6035040" y="2423160"/>
-            <a:ext cx="5760720" cy="3520440"/>
-          </a:xfrm>
-          <a:prstGeom prst="rect">
-            <a:avLst/>
-          </a:prstGeom>
-          <a:noFill/>
-        </p:spPr>
-        <p:txBody>
-          <a:bodyPr wrap="square">
-            <a:spAutoFit/>
-          </a:bodyPr>
-          <a:lstStyle/>
-          <a:p>
-            <a:pPr algn="l"/>
-            <a:r>
-              <a:rPr sz="1150" b="0" i="0">
-                <a:solidFill>
-                  <a:srgbClr val="1A1A1A"/>
-                </a:solidFill>
-                <a:latin typeface="맑은 고딕"/>
-              </a:rPr>
-              <a:t>① Threshold 하향 (0.50 → 0.30~0.40) ← 즉시 적용 가능
-   Streamlit 슬라이더로 현장에서 바로 조정
-   예상: Recall 0.68 → 0.80~0.85
-② Class 1 가중치 증가 (재학습 필요)
-   class_weight={0:1.0, 1:2.0~3.0}
-   → 학습 시 고장 샘플에 더 높은 손실 부과
-③ SMOTE 오버샘플링
-   Class 1(74건) 합성 샘플 추가
-   → 불균형 해소, 고장 패턴 학습 강화
-④ 피처 추가 (장기 개선)
-   진동 변화율, 주파수 도메인 특성</a:t>
-            </a:r>
-          </a:p>
-        </p:txBody>
-      </p:sp>
-      <p:sp>
-        <p:nvSpPr>
-          <p:cNvPr id="15" name="Rectangle 14"/>
-          <p:cNvSpPr/>
-          <p:nvPr/>
-        </p:nvSpPr>
-        <p:spPr>
-          <a:xfrm>
-            <a:off x="274320" y="6199632"/>
-            <a:ext cx="11612880" cy="274320"/>
-          </a:xfrm>
-          <a:prstGeom prst="rect">
-            <a:avLst/>
-          </a:prstGeom>
-          <a:solidFill>
-            <a:srgbClr val="1F4E79"/>
-          </a:solidFill>
-          <a:ln>
-            <a:noFill/>
-          </a:ln>
-        </p:spPr>
-        <p:style>
-          <a:lnRef idx="1">
-            <a:schemeClr val="accent1"/>
-          </a:lnRef>
-          <a:fillRef idx="3">
-            <a:schemeClr val="accent1"/>
-          </a:fillRef>
-          <a:effectRef idx="2">
-            <a:schemeClr val="accent1"/>
-          </a:effectRef>
-          <a:fontRef idx="minor">
-            <a:schemeClr val="lt1"/>
-          </a:fontRef>
-        </p:style>
-        <p:txBody>
-          <a:bodyPr rtlCol="0" anchor="ctr"/>
-          <a:lstStyle/>
-          <a:p>
-            <a:pPr algn="ctr"/>
-          </a:p>
-        </p:txBody>
-      </p:sp>
-      <p:sp>
-        <p:nvSpPr>
-          <p:cNvPr id="16" name="TextBox 15"/>
-          <p:cNvSpPr txBox="1"/>
-          <p:nvPr/>
-        </p:nvSpPr>
-        <p:spPr>
-          <a:xfrm>
-            <a:off x="365760" y="6217920"/>
-            <a:ext cx="11430000" cy="256032"/>
-          </a:xfrm>
-          <a:prstGeom prst="rect">
-            <a:avLst/>
-          </a:prstGeom>
-          <a:noFill/>
-        </p:spPr>
-        <p:txBody>
-          <a:bodyPr wrap="square">
-            <a:spAutoFit/>
-          </a:bodyPr>
-          <a:lstStyle/>
-          <a:p>
-            <a:pPr algn="ctr"/>
-            <a:r>
-              <a:rPr sz="1100" b="1" i="0">
-                <a:solidFill>
-                  <a:srgbClr val="FFFFFF"/>
-                </a:solidFill>
-                <a:latin typeface="맑은 고딕"/>
-              </a:rPr>
-              <a:t>1순위: Threshold 하향(슬라이더)  →  2순위: class_weight 재학습  →  3순위: SMOTE  →  4순위: 피처 엔지니어링 (Phase 2)</a:t>
             </a:r>
           </a:p>
         </p:txBody>
@@ -12572,6 +12201,615 @@
       <p:grpSpPr/>
       <p:sp>
         <p:nvSpPr>
+          <p:cNvPr id="2" name="Rectangle 1"/>
+          <p:cNvSpPr/>
+          <p:nvPr/>
+        </p:nvSpPr>
+        <p:spPr>
+          <a:xfrm>
+            <a:off x="0" y="0"/>
+            <a:ext cx="12188952" cy="960120"/>
+          </a:xfrm>
+          <a:prstGeom prst="rect">
+            <a:avLst/>
+          </a:prstGeom>
+          <a:solidFill>
+            <a:srgbClr val="1F4E79"/>
+          </a:solidFill>
+          <a:ln>
+            <a:noFill/>
+          </a:ln>
+        </p:spPr>
+        <p:style>
+          <a:lnRef idx="1">
+            <a:schemeClr val="accent1"/>
+          </a:lnRef>
+          <a:fillRef idx="3">
+            <a:schemeClr val="accent1"/>
+          </a:fillRef>
+          <a:effectRef idx="2">
+            <a:schemeClr val="accent1"/>
+          </a:effectRef>
+          <a:fontRef idx="minor">
+            <a:schemeClr val="lt1"/>
+          </a:fontRef>
+        </p:style>
+        <p:txBody>
+          <a:bodyPr rtlCol="0" anchor="ctr"/>
+          <a:lstStyle/>
+          <a:p>
+            <a:pPr algn="ctr"/>
+          </a:p>
+        </p:txBody>
+      </p:sp>
+      <p:sp>
+        <p:nvSpPr>
+          <p:cNvPr id="3" name="Rectangle 2"/>
+          <p:cNvSpPr/>
+          <p:nvPr/>
+        </p:nvSpPr>
+        <p:spPr>
+          <a:xfrm>
+            <a:off x="0" y="6784848"/>
+            <a:ext cx="12188952" cy="73152"/>
+          </a:xfrm>
+          <a:prstGeom prst="rect">
+            <a:avLst/>
+          </a:prstGeom>
+          <a:solidFill>
+            <a:srgbClr val="2E75B6"/>
+          </a:solidFill>
+          <a:ln>
+            <a:noFill/>
+          </a:ln>
+        </p:spPr>
+        <p:style>
+          <a:lnRef idx="1">
+            <a:schemeClr val="accent1"/>
+          </a:lnRef>
+          <a:fillRef idx="3">
+            <a:schemeClr val="accent1"/>
+          </a:fillRef>
+          <a:effectRef idx="2">
+            <a:schemeClr val="accent1"/>
+          </a:effectRef>
+          <a:fontRef idx="minor">
+            <a:schemeClr val="lt1"/>
+          </a:fontRef>
+        </p:style>
+        <p:txBody>
+          <a:bodyPr rtlCol="0" anchor="ctr"/>
+          <a:lstStyle/>
+          <a:p>
+            <a:pPr algn="ctr"/>
+          </a:p>
+        </p:txBody>
+      </p:sp>
+      <p:sp>
+        <p:nvSpPr>
+          <p:cNvPr id="4" name="TextBox 3"/>
+          <p:cNvSpPr txBox="1"/>
+          <p:nvPr/>
+        </p:nvSpPr>
+        <p:spPr>
+          <a:xfrm>
+            <a:off x="274320" y="54864"/>
+            <a:ext cx="10058400" cy="594360"/>
+          </a:xfrm>
+          <a:prstGeom prst="rect">
+            <a:avLst/>
+          </a:prstGeom>
+          <a:noFill/>
+        </p:spPr>
+        <p:txBody>
+          <a:bodyPr wrap="square">
+            <a:spAutoFit/>
+          </a:bodyPr>
+          <a:lstStyle/>
+          <a:p>
+            <a:pPr algn="l"/>
+            <a:r>
+              <a:rPr sz="2600" b="1" i="0">
+                <a:solidFill>
+                  <a:srgbClr val="FFFFFF"/>
+                </a:solidFill>
+                <a:latin typeface="맑은 고딕"/>
+              </a:rPr>
+              <a:t>FP / FN 개선 방향 분석</a:t>
+            </a:r>
+          </a:p>
+        </p:txBody>
+      </p:sp>
+      <p:sp>
+        <p:nvSpPr>
+          <p:cNvPr id="5" name="TextBox 4"/>
+          <p:cNvSpPr txBox="1"/>
+          <p:nvPr/>
+        </p:nvSpPr>
+        <p:spPr>
+          <a:xfrm>
+            <a:off x="320040" y="621792"/>
+            <a:ext cx="11430000" cy="320040"/>
+          </a:xfrm>
+          <a:prstGeom prst="rect">
+            <a:avLst/>
+          </a:prstGeom>
+          <a:noFill/>
+        </p:spPr>
+        <p:txBody>
+          <a:bodyPr wrap="square">
+            <a:spAutoFit/>
+          </a:bodyPr>
+          <a:lstStyle/>
+          <a:p>
+            <a:pPr algn="l"/>
+            <a:r>
+              <a:rPr sz="1200" b="0" i="1">
+                <a:solidFill>
+                  <a:srgbClr val="BDD7EE"/>
+                </a:solidFill>
+                <a:latin typeface="맑은 고딕"/>
+              </a:rPr>
+              <a:t>False Positive(오경보) vs False Negative(미감지)  ·  우선순위 기반 개선 로드맵</a:t>
+            </a:r>
+          </a:p>
+        </p:txBody>
+      </p:sp>
+      <p:sp>
+        <p:nvSpPr>
+          <p:cNvPr id="6" name="Rectangle 5"/>
+          <p:cNvSpPr/>
+          <p:nvPr/>
+        </p:nvSpPr>
+        <p:spPr>
+          <a:xfrm>
+            <a:off x="274320" y="1051560"/>
+            <a:ext cx="11612880" cy="777240"/>
+          </a:xfrm>
+          <a:prstGeom prst="rect">
+            <a:avLst/>
+          </a:prstGeom>
+          <a:solidFill>
+            <a:srgbClr val="D6E4F7"/>
+          </a:solidFill>
+          <a:ln>
+            <a:noFill/>
+          </a:ln>
+        </p:spPr>
+        <p:style>
+          <a:lnRef idx="1">
+            <a:schemeClr val="accent1"/>
+          </a:lnRef>
+          <a:fillRef idx="3">
+            <a:schemeClr val="accent1"/>
+          </a:fillRef>
+          <a:effectRef idx="2">
+            <a:schemeClr val="accent1"/>
+          </a:effectRef>
+          <a:fontRef idx="minor">
+            <a:schemeClr val="lt1"/>
+          </a:fontRef>
+        </p:style>
+        <p:txBody>
+          <a:bodyPr rtlCol="0" anchor="ctr"/>
+          <a:lstStyle/>
+          <a:p>
+            <a:pPr algn="ctr"/>
+          </a:p>
+        </p:txBody>
+      </p:sp>
+      <p:sp>
+        <p:nvSpPr>
+          <p:cNvPr id="7" name="TextBox 6"/>
+          <p:cNvSpPr txBox="1"/>
+          <p:nvPr/>
+        </p:nvSpPr>
+        <p:spPr>
+          <a:xfrm>
+            <a:off x="365760" y="1078992"/>
+            <a:ext cx="11430000" cy="347472"/>
+          </a:xfrm>
+          <a:prstGeom prst="rect">
+            <a:avLst/>
+          </a:prstGeom>
+          <a:noFill/>
+        </p:spPr>
+        <p:txBody>
+          <a:bodyPr wrap="square">
+            <a:spAutoFit/>
+          </a:bodyPr>
+          <a:lstStyle/>
+          <a:p>
+            <a:pPr algn="l"/>
+            <a:r>
+              <a:rPr sz="1300" b="1" i="0">
+                <a:solidFill>
+                  <a:srgbClr val="1F4E79"/>
+                </a:solidFill>
+                <a:latin typeface="맑은 고딕"/>
+              </a:rPr>
+              <a:t>오경보(FP) vs 미감지(FN) — 제조업 관점</a:t>
+            </a:r>
+          </a:p>
+        </p:txBody>
+      </p:sp>
+      <p:sp>
+        <p:nvSpPr>
+          <p:cNvPr id="8" name="TextBox 7"/>
+          <p:cNvSpPr txBox="1"/>
+          <p:nvPr/>
+        </p:nvSpPr>
+        <p:spPr>
+          <a:xfrm>
+            <a:off x="365760" y="1435608"/>
+            <a:ext cx="11430000" cy="347472"/>
+          </a:xfrm>
+          <a:prstGeom prst="rect">
+            <a:avLst/>
+          </a:prstGeom>
+          <a:noFill/>
+        </p:spPr>
+        <p:txBody>
+          <a:bodyPr wrap="square">
+            <a:spAutoFit/>
+          </a:bodyPr>
+          <a:lstStyle/>
+          <a:p>
+            <a:pPr algn="l"/>
+            <a:r>
+              <a:rPr sz="1150" b="0" i="0">
+                <a:solidFill>
+                  <a:srgbClr val="1A1A1A"/>
+                </a:solidFill>
+                <a:latin typeface="맑은 고딕"/>
+              </a:rPr>
+              <a:t>FP(오경보): 안전 측면 위험 없음, 불필요한 유지보수 비용 발생  |  FN(미감지): 실제 고장 방치 → 설비 파손·생산 중단 → 비용/안전 모두 위험 ★★★</a:t>
+            </a:r>
+          </a:p>
+        </p:txBody>
+      </p:sp>
+      <p:sp>
+        <p:nvSpPr>
+          <p:cNvPr id="9" name="Rectangle 8"/>
+          <p:cNvSpPr/>
+          <p:nvPr/>
+        </p:nvSpPr>
+        <p:spPr>
+          <a:xfrm>
+            <a:off x="274320" y="1965960"/>
+            <a:ext cx="5394960" cy="4114800"/>
+          </a:xfrm>
+          <a:prstGeom prst="rect">
+            <a:avLst/>
+          </a:prstGeom>
+          <a:solidFill>
+            <a:srgbClr val="F2F2F2"/>
+          </a:solidFill>
+          <a:ln>
+            <a:noFill/>
+          </a:ln>
+        </p:spPr>
+        <p:style>
+          <a:lnRef idx="1">
+            <a:schemeClr val="accent1"/>
+          </a:lnRef>
+          <a:fillRef idx="3">
+            <a:schemeClr val="accent1"/>
+          </a:fillRef>
+          <a:effectRef idx="2">
+            <a:schemeClr val="accent1"/>
+          </a:effectRef>
+          <a:fontRef idx="minor">
+            <a:schemeClr val="lt1"/>
+          </a:fontRef>
+        </p:style>
+        <p:txBody>
+          <a:bodyPr rtlCol="0" anchor="ctr"/>
+          <a:lstStyle/>
+          <a:p>
+            <a:pPr algn="ctr"/>
+          </a:p>
+        </p:txBody>
+      </p:sp>
+      <p:sp>
+        <p:nvSpPr>
+          <p:cNvPr id="10" name="TextBox 9"/>
+          <p:cNvSpPr txBox="1"/>
+          <p:nvPr/>
+        </p:nvSpPr>
+        <p:spPr>
+          <a:xfrm>
+            <a:off x="365760" y="2011680"/>
+            <a:ext cx="5212080" cy="365760"/>
+          </a:xfrm>
+          <a:prstGeom prst="rect">
+            <a:avLst/>
+          </a:prstGeom>
+          <a:noFill/>
+        </p:spPr>
+        <p:txBody>
+          <a:bodyPr wrap="square">
+            <a:spAutoFit/>
+          </a:bodyPr>
+          <a:lstStyle/>
+          <a:p>
+            <a:pPr algn="l"/>
+            <a:r>
+              <a:rPr sz="1200" b="1" i="0">
+                <a:solidFill>
+                  <a:srgbClr val="1F4E79"/>
+                </a:solidFill>
+                <a:latin typeface="맑은 고딕"/>
+              </a:rPr>
+              <a:t>FP = 12 개선 (오경보 줄이기)</a:t>
+            </a:r>
+          </a:p>
+        </p:txBody>
+      </p:sp>
+      <p:sp>
+        <p:nvSpPr>
+          <p:cNvPr id="11" name="TextBox 10"/>
+          <p:cNvSpPr txBox="1"/>
+          <p:nvPr/>
+        </p:nvSpPr>
+        <p:spPr>
+          <a:xfrm>
+            <a:off x="365760" y="2423160"/>
+            <a:ext cx="5212080" cy="3520440"/>
+          </a:xfrm>
+          <a:prstGeom prst="rect">
+            <a:avLst/>
+          </a:prstGeom>
+          <a:noFill/>
+        </p:spPr>
+        <p:txBody>
+          <a:bodyPr wrap="square">
+            <a:spAutoFit/>
+          </a:bodyPr>
+          <a:lstStyle/>
+          <a:p>
+            <a:pPr algn="l"/>
+            <a:r>
+              <a:rPr sz="1150" b="0" i="0">
+                <a:solidFill>
+                  <a:srgbClr val="1A1A1A"/>
+                </a:solidFill>
+                <a:latin typeface="맑은 고딕"/>
+              </a:rPr>
+              <a:t>① Threshold 상향 (0.50 → 0.65~0.75)
+   → 예측 확신도 높을 때만 고장 판정
+   → FP 감소, FN 증가 가능성
+② 정상 구간 말기 데이터 추가 수집
+   → 고장 초기와 구분되는 패턴 학습
+③ Class 0 가중치 소폭 증가
+   (class_weight={0:1.2, 1:1.0})
+⚠ 주의: FP를 줄이면 FN이 증가할 수 있음
+  → 제조업에서는 FN 최소화가 우선</a:t>
+            </a:r>
+          </a:p>
+        </p:txBody>
+      </p:sp>
+      <p:sp>
+        <p:nvSpPr>
+          <p:cNvPr id="12" name="Rectangle 11"/>
+          <p:cNvSpPr/>
+          <p:nvPr/>
+        </p:nvSpPr>
+        <p:spPr>
+          <a:xfrm>
+            <a:off x="5943600" y="1965960"/>
+            <a:ext cx="5943600" cy="4114800"/>
+          </a:xfrm>
+          <a:prstGeom prst="rect">
+            <a:avLst/>
+          </a:prstGeom>
+          <a:solidFill>
+            <a:srgbClr val="FFF3CD"/>
+          </a:solidFill>
+          <a:ln>
+            <a:noFill/>
+          </a:ln>
+        </p:spPr>
+        <p:style>
+          <a:lnRef idx="1">
+            <a:schemeClr val="accent1"/>
+          </a:lnRef>
+          <a:fillRef idx="3">
+            <a:schemeClr val="accent1"/>
+          </a:fillRef>
+          <a:effectRef idx="2">
+            <a:schemeClr val="accent1"/>
+          </a:effectRef>
+          <a:fontRef idx="minor">
+            <a:schemeClr val="lt1"/>
+          </a:fontRef>
+        </p:style>
+        <p:txBody>
+          <a:bodyPr rtlCol="0" anchor="ctr"/>
+          <a:lstStyle/>
+          <a:p>
+            <a:pPr algn="ctr"/>
+          </a:p>
+        </p:txBody>
+      </p:sp>
+      <p:sp>
+        <p:nvSpPr>
+          <p:cNvPr id="13" name="TextBox 12"/>
+          <p:cNvSpPr txBox="1"/>
+          <p:nvPr/>
+        </p:nvSpPr>
+        <p:spPr>
+          <a:xfrm>
+            <a:off x="6035040" y="2011680"/>
+            <a:ext cx="5760720" cy="365760"/>
+          </a:xfrm>
+          <a:prstGeom prst="rect">
+            <a:avLst/>
+          </a:prstGeom>
+          <a:noFill/>
+        </p:spPr>
+        <p:txBody>
+          <a:bodyPr wrap="square">
+            <a:spAutoFit/>
+          </a:bodyPr>
+          <a:lstStyle/>
+          <a:p>
+            <a:pPr algn="l"/>
+            <a:r>
+              <a:rPr sz="1200" b="1" i="0">
+                <a:solidFill>
+                  <a:srgbClr val="7B3600"/>
+                </a:solidFill>
+                <a:latin typeface="맑은 고딕"/>
+              </a:rPr>
+              <a:t>FN = 24 개선 ★ 우선순위 높음 (미감지 줄이기)</a:t>
+            </a:r>
+          </a:p>
+        </p:txBody>
+      </p:sp>
+      <p:sp>
+        <p:nvSpPr>
+          <p:cNvPr id="14" name="TextBox 13"/>
+          <p:cNvSpPr txBox="1"/>
+          <p:nvPr/>
+        </p:nvSpPr>
+        <p:spPr>
+          <a:xfrm>
+            <a:off x="6035040" y="2423160"/>
+            <a:ext cx="5760720" cy="3520440"/>
+          </a:xfrm>
+          <a:prstGeom prst="rect">
+            <a:avLst/>
+          </a:prstGeom>
+          <a:noFill/>
+        </p:spPr>
+        <p:txBody>
+          <a:bodyPr wrap="square">
+            <a:spAutoFit/>
+          </a:bodyPr>
+          <a:lstStyle/>
+          <a:p>
+            <a:pPr algn="l"/>
+            <a:r>
+              <a:rPr sz="1150" b="0" i="0">
+                <a:solidFill>
+                  <a:srgbClr val="1A1A1A"/>
+                </a:solidFill>
+                <a:latin typeface="맑은 고딕"/>
+              </a:rPr>
+              <a:t>① Threshold 하향 (0.50 → 0.30~0.40) ← 즉시 적용 가능
+   Streamlit 슬라이더로 현장에서 바로 조정
+   예상: Recall 0.68 → 0.80~0.85
+② Class 1 가중치 증가 (재학습 필요)
+   class_weight={0:1.0, 1:2.0~3.0}
+   → 학습 시 고장 샘플에 더 높은 손실 부과
+③ SMOTE 오버샘플링
+   Class 1(74건) 합성 샘플 추가
+   → 불균형 해소, 고장 패턴 학습 강화
+④ 피처 추가 (장기 개선)
+   진동 변화율, 주파수 도메인 특성</a:t>
+            </a:r>
+          </a:p>
+        </p:txBody>
+      </p:sp>
+      <p:sp>
+        <p:nvSpPr>
+          <p:cNvPr id="15" name="Rectangle 14"/>
+          <p:cNvSpPr/>
+          <p:nvPr/>
+        </p:nvSpPr>
+        <p:spPr>
+          <a:xfrm>
+            <a:off x="274320" y="6199632"/>
+            <a:ext cx="11612880" cy="274320"/>
+          </a:xfrm>
+          <a:prstGeom prst="rect">
+            <a:avLst/>
+          </a:prstGeom>
+          <a:solidFill>
+            <a:srgbClr val="1F4E79"/>
+          </a:solidFill>
+          <a:ln>
+            <a:noFill/>
+          </a:ln>
+        </p:spPr>
+        <p:style>
+          <a:lnRef idx="1">
+            <a:schemeClr val="accent1"/>
+          </a:lnRef>
+          <a:fillRef idx="3">
+            <a:schemeClr val="accent1"/>
+          </a:fillRef>
+          <a:effectRef idx="2">
+            <a:schemeClr val="accent1"/>
+          </a:effectRef>
+          <a:fontRef idx="minor">
+            <a:schemeClr val="lt1"/>
+          </a:fontRef>
+        </p:style>
+        <p:txBody>
+          <a:bodyPr rtlCol="0" anchor="ctr"/>
+          <a:lstStyle/>
+          <a:p>
+            <a:pPr algn="ctr"/>
+          </a:p>
+        </p:txBody>
+      </p:sp>
+      <p:sp>
+        <p:nvSpPr>
+          <p:cNvPr id="16" name="TextBox 15"/>
+          <p:cNvSpPr txBox="1"/>
+          <p:nvPr/>
+        </p:nvSpPr>
+        <p:spPr>
+          <a:xfrm>
+            <a:off x="365760" y="6217920"/>
+            <a:ext cx="11430000" cy="256032"/>
+          </a:xfrm>
+          <a:prstGeom prst="rect">
+            <a:avLst/>
+          </a:prstGeom>
+          <a:noFill/>
+        </p:spPr>
+        <p:txBody>
+          <a:bodyPr wrap="square">
+            <a:spAutoFit/>
+          </a:bodyPr>
+          <a:lstStyle/>
+          <a:p>
+            <a:pPr algn="ctr"/>
+            <a:r>
+              <a:rPr sz="1100" b="1" i="0">
+                <a:solidFill>
+                  <a:srgbClr val="FFFFFF"/>
+                </a:solidFill>
+                <a:latin typeface="맑은 고딕"/>
+              </a:rPr>
+              <a:t>1순위: Threshold 하향(슬라이더)  →  2순위: class_weight 재학습  →  3순위: SMOTE  →  4순위: 피처 엔지니어링 (Phase 2)</a:t>
+            </a:r>
+          </a:p>
+        </p:txBody>
+      </p:sp>
+    </p:spTree>
+  </p:cSld>
+  <p:clrMapOvr>
+    <a:masterClrMapping/>
+  </p:clrMapOvr>
+</p:sld>
+</file>
+
+<file path=ppt/slides/slide18.xml><?xml version="1.0" encoding="utf-8"?>
+<p:sld xmlns:a="http://schemas.openxmlformats.org/drawingml/2006/main" xmlns:p="http://schemas.openxmlformats.org/presentationml/2006/main" xmlns:r="http://schemas.openxmlformats.org/officeDocument/2006/relationships">
+  <p:cSld>
+    <p:spTree>
+      <p:nvGrpSpPr>
+        <p:cNvPr id="1" name=""/>
+        <p:cNvGrpSpPr/>
+        <p:nvPr/>
+      </p:nvGrpSpPr>
+      <p:grpSpPr/>
+      <p:sp>
+        <p:nvSpPr>
           <p:cNvPr id="2" name="TextBox 1"/>
           <p:cNvSpPr txBox="1"/>
           <p:nvPr/>
@@ -12657,7 +12895,7 @@
 </p:sld>
 </file>
 
-<file path=ppt/slides/slide18.xml><?xml version="1.0" encoding="utf-8"?>
+<file path=ppt/slides/slide19.xml><?xml version="1.0" encoding="utf-8"?>
 <p:sld xmlns:a="http://schemas.openxmlformats.org/drawingml/2006/main" xmlns:p="http://schemas.openxmlformats.org/presentationml/2006/main" xmlns:r="http://schemas.openxmlformats.org/officeDocument/2006/relationships">
   <p:cSld>
     <p:spTree>
@@ -12759,144 +12997,6 @@
   rms_ratio (h/v 불균형): 방향성 이상 반영
   temp_mean: 데이터 없어 0 처리 -&gt; 기여도 0 (온도 센서 미활용 환경)
   결론: 수평 진동의 크기 + 충격성 조합이 열화 여부 결정에 지배적</a:t>
-            </a:r>
-          </a:p>
-        </p:txBody>
-      </p:sp>
-    </p:spTree>
-  </p:cSld>
-  <p:clrMapOvr>
-    <a:masterClrMapping/>
-  </p:clrMapOvr>
-</p:sld>
-</file>
-
-<file path=ppt/slides/slide19.xml><?xml version="1.0" encoding="utf-8"?>
-<p:sld xmlns:a="http://schemas.openxmlformats.org/drawingml/2006/main" xmlns:p="http://schemas.openxmlformats.org/presentationml/2006/main" xmlns:r="http://schemas.openxmlformats.org/officeDocument/2006/relationships">
-  <p:cSld>
-    <p:spTree>
-      <p:nvGrpSpPr>
-        <p:cNvPr id="1" name=""/>
-        <p:cNvGrpSpPr/>
-        <p:nvPr/>
-      </p:nvGrpSpPr>
-      <p:grpSpPr/>
-      <p:sp>
-        <p:nvSpPr>
-          <p:cNvPr id="2" name="TextBox 1"/>
-          <p:cNvSpPr txBox="1"/>
-          <p:nvPr/>
-        </p:nvSpPr>
-        <p:spPr>
-          <a:xfrm>
-            <a:off x="457200" y="320040"/>
-            <a:ext cx="11274552" cy="594360"/>
-          </a:xfrm>
-          <a:prstGeom prst="rect">
-            <a:avLst/>
-          </a:prstGeom>
-          <a:noFill/>
-        </p:spPr>
-        <p:txBody>
-          <a:bodyPr wrap="none">
-            <a:spAutoFit/>
-          </a:bodyPr>
-          <a:lstStyle/>
-          <a:p>
-            <a:pPr algn="l"/>
-            <a:r>
-              <a:rPr sz="2200" b="1">
-                <a:solidFill>
-                  <a:srgbClr val="1F4E79"/>
-                </a:solidFill>
-              </a:rPr>
-              <a:t>SHAP - GRU v2 RUL 예측 (왼쪽) &amp; 두 모델 피처 중요도 비교 (오른쪽)</a:t>
-            </a:r>
-          </a:p>
-        </p:txBody>
-      </p:sp>
-      <p:pic>
-        <p:nvPicPr>
-          <p:cNvPr id="3" name="Picture 2" descr="S2_shap_gru.png"/>
-          <p:cNvPicPr>
-            <a:picLocks noChangeAspect="1"/>
-          </p:cNvPicPr>
-          <p:nvPr/>
-        </p:nvPicPr>
-        <p:blipFill>
-          <a:blip r:embed="rId2"/>
-          <a:stretch>
-            <a:fillRect/>
-          </a:stretch>
-        </p:blipFill>
-        <p:spPr>
-          <a:xfrm>
-            <a:off x="274320" y="914400"/>
-            <a:ext cx="4206240" cy="2786727"/>
-          </a:xfrm>
-          <a:prstGeom prst="rect">
-            <a:avLst/>
-          </a:prstGeom>
-        </p:spPr>
-      </p:pic>
-      <p:pic>
-        <p:nvPicPr>
-          <p:cNvPr id="4" name="Picture 3" descr="S3_shap_bar.png"/>
-          <p:cNvPicPr>
-            <a:picLocks noChangeAspect="1"/>
-          </p:cNvPicPr>
-          <p:nvPr/>
-        </p:nvPicPr>
-        <p:blipFill>
-          <a:blip r:embed="rId3"/>
-          <a:stretch>
-            <a:fillRect/>
-          </a:stretch>
-        </p:blipFill>
-        <p:spPr>
-          <a:xfrm>
-            <a:off x="4663440" y="914400"/>
-            <a:ext cx="4297680" cy="1611630"/>
-          </a:xfrm>
-          <a:prstGeom prst="rect">
-            <a:avLst/>
-          </a:prstGeom>
-        </p:spPr>
-      </p:pic>
-      <p:sp>
-        <p:nvSpPr>
-          <p:cNvPr id="5" name="TextBox 4"/>
-          <p:cNvSpPr txBox="1"/>
-          <p:nvPr/>
-        </p:nvSpPr>
-        <p:spPr>
-          <a:xfrm>
-            <a:off x="457200" y="5120640"/>
-            <a:ext cx="11274552" cy="1645920"/>
-          </a:xfrm>
-          <a:prstGeom prst="rect">
-            <a:avLst/>
-          </a:prstGeom>
-          <a:noFill/>
-        </p:spPr>
-        <p:txBody>
-          <a:bodyPr wrap="square">
-            <a:spAutoFit/>
-          </a:bodyPr>
-          <a:lstStyle/>
-          <a:p>
-            <a:r>
-              <a:rPr sz="1000">
-                <a:solidFill>
-                  <a:srgbClr val="333333"/>
-                </a:solidFill>
-              </a:rPr>
-              <a:t>[GRU RUL 모델 - 왼쪽]
-  energy (총 진동 에너지) + h_rms 가 RUL 예측에 최대 기여 | 에너지 높을수록 잔여수명 단축(RUL-)
-[두 모델 비교 - 오른쪽]
-  분류(열화감지): h_rms &gt; h_kurt &gt; rms_ratio 순
-  GRU(RUL회귀):  energy &gt; h_rms &gt; health_idx 순
-  -&gt; energy 파생 피처가 RUL 회귀에서 추가 변별력 제공 / 두 모델 모두 h_rms 핵심</a:t>
             </a:r>
           </a:p>
         </p:txBody>
@@ -13542,6 +13642,330 @@
                 <a:latin typeface="맑은 고딕"/>
               </a:rPr>
               <a:t>부록 B. 데이터 프로파일링 리포트</a:t>
+            </a:r>
+          </a:p>
+        </p:txBody>
+      </p:sp>
+    </p:spTree>
+  </p:cSld>
+  <p:clrMapOvr>
+    <a:masterClrMapping/>
+  </p:clrMapOvr>
+</p:sld>
+</file>
+
+<file path=ppt/slides/slide20.xml><?xml version="1.0" encoding="utf-8"?>
+<p:sld xmlns:a="http://schemas.openxmlformats.org/drawingml/2006/main" xmlns:p="http://schemas.openxmlformats.org/presentationml/2006/main" xmlns:r="http://schemas.openxmlformats.org/officeDocument/2006/relationships">
+  <p:cSld>
+    <p:spTree>
+      <p:nvGrpSpPr>
+        <p:cNvPr id="1" name=""/>
+        <p:cNvGrpSpPr/>
+        <p:nvPr/>
+      </p:nvGrpSpPr>
+      <p:grpSpPr/>
+      <p:sp>
+        <p:nvSpPr>
+          <p:cNvPr id="2" name="TextBox 1"/>
+          <p:cNvSpPr txBox="1"/>
+          <p:nvPr/>
+        </p:nvSpPr>
+        <p:spPr>
+          <a:xfrm>
+            <a:off x="457200" y="320040"/>
+            <a:ext cx="11274552" cy="594360"/>
+          </a:xfrm>
+          <a:prstGeom prst="rect">
+            <a:avLst/>
+          </a:prstGeom>
+          <a:noFill/>
+        </p:spPr>
+        <p:txBody>
+          <a:bodyPr wrap="none">
+            <a:spAutoFit/>
+          </a:bodyPr>
+          <a:lstStyle/>
+          <a:p>
+            <a:pPr algn="l"/>
+            <a:r>
+              <a:rPr sz="2200" b="1">
+                <a:solidFill>
+                  <a:srgbClr val="1F4E79"/>
+                </a:solidFill>
+              </a:rPr>
+              <a:t>SHAP - GRU v2 RUL 예측 (왼쪽) &amp; 두 모델 피처 중요도 비교 (오른쪽)</a:t>
+            </a:r>
+          </a:p>
+        </p:txBody>
+      </p:sp>
+      <p:pic>
+        <p:nvPicPr>
+          <p:cNvPr id="3" name="Picture 2" descr="S2_shap_gru.png"/>
+          <p:cNvPicPr>
+            <a:picLocks noChangeAspect="1"/>
+          </p:cNvPicPr>
+          <p:nvPr/>
+        </p:nvPicPr>
+        <p:blipFill>
+          <a:blip r:embed="rId2"/>
+          <a:stretch>
+            <a:fillRect/>
+          </a:stretch>
+        </p:blipFill>
+        <p:spPr>
+          <a:xfrm>
+            <a:off x="274320" y="914400"/>
+            <a:ext cx="4206240" cy="2786727"/>
+          </a:xfrm>
+          <a:prstGeom prst="rect">
+            <a:avLst/>
+          </a:prstGeom>
+        </p:spPr>
+      </p:pic>
+      <p:pic>
+        <p:nvPicPr>
+          <p:cNvPr id="4" name="Picture 3" descr="S3_shap_bar.png"/>
+          <p:cNvPicPr>
+            <a:picLocks noChangeAspect="1"/>
+          </p:cNvPicPr>
+          <p:nvPr/>
+        </p:nvPicPr>
+        <p:blipFill>
+          <a:blip r:embed="rId3"/>
+          <a:stretch>
+            <a:fillRect/>
+          </a:stretch>
+        </p:blipFill>
+        <p:spPr>
+          <a:xfrm>
+            <a:off x="4663440" y="914400"/>
+            <a:ext cx="4297680" cy="1611630"/>
+          </a:xfrm>
+          <a:prstGeom prst="rect">
+            <a:avLst/>
+          </a:prstGeom>
+        </p:spPr>
+      </p:pic>
+      <p:sp>
+        <p:nvSpPr>
+          <p:cNvPr id="5" name="TextBox 4"/>
+          <p:cNvSpPr txBox="1"/>
+          <p:nvPr/>
+        </p:nvSpPr>
+        <p:spPr>
+          <a:xfrm>
+            <a:off x="457200" y="5120640"/>
+            <a:ext cx="11274552" cy="1645920"/>
+          </a:xfrm>
+          <a:prstGeom prst="rect">
+            <a:avLst/>
+          </a:prstGeom>
+          <a:noFill/>
+        </p:spPr>
+        <p:txBody>
+          <a:bodyPr wrap="square">
+            <a:spAutoFit/>
+          </a:bodyPr>
+          <a:lstStyle/>
+          <a:p>
+            <a:r>
+              <a:rPr sz="1000">
+                <a:solidFill>
+                  <a:srgbClr val="333333"/>
+                </a:solidFill>
+              </a:rPr>
+              <a:t>[GRU RUL 모델 - 왼쪽]
+  energy (총 진동 에너지) + h_rms 가 RUL 예측에 최대 기여 | 에너지 높을수록 잔여수명 단축(RUL-)
+[두 모델 비교 - 오른쪽]
+  분류(열화감지): h_rms &gt; h_kurt &gt; rms_ratio 순
+  GRU(RUL회귀):  energy &gt; h_rms &gt; health_idx 순
+  -&gt; energy 파생 피처가 RUL 회귀에서 추가 변별력 제공 / 두 모델 모두 h_rms 핵심</a:t>
+            </a:r>
+          </a:p>
+        </p:txBody>
+      </p:sp>
+    </p:spTree>
+  </p:cSld>
+  <p:clrMapOvr>
+    <a:masterClrMapping/>
+  </p:clrMapOvr>
+</p:sld>
+</file>
+
+<file path=ppt/slides/slide21.xml><?xml version="1.0" encoding="utf-8"?>
+<p:sld xmlns:a="http://schemas.openxmlformats.org/drawingml/2006/main" xmlns:p="http://schemas.openxmlformats.org/presentationml/2006/main" xmlns:r="http://schemas.openxmlformats.org/officeDocument/2006/relationships">
+  <p:cSld>
+    <p:spTree>
+      <p:nvGrpSpPr>
+        <p:cNvPr id="1" name=""/>
+        <p:cNvGrpSpPr/>
+        <p:nvPr/>
+      </p:nvGrpSpPr>
+      <p:grpSpPr/>
+      <p:sp>
+        <p:nvSpPr>
+          <p:cNvPr id="2" name="TextBox 1"/>
+          <p:cNvSpPr txBox="1"/>
+          <p:nvPr/>
+        </p:nvSpPr>
+        <p:spPr>
+          <a:xfrm>
+            <a:off x="274320" y="91440"/>
+            <a:ext cx="11640312" cy="502920"/>
+          </a:xfrm>
+          <a:prstGeom prst="rect">
+            <a:avLst/>
+          </a:prstGeom>
+          <a:noFill/>
+        </p:spPr>
+        <p:txBody>
+          <a:bodyPr wrap="square">
+            <a:spAutoFit/>
+          </a:bodyPr>
+          <a:lstStyle/>
+          <a:p>
+            <a:pPr algn="l"/>
+            <a:r>
+              <a:rPr sz="1800" b="1">
+                <a:solidFill>
+                  <a:srgbClr val="1F4E79"/>
+                </a:solidFill>
+              </a:rPr>
+              <a:t>SHAP 분석으로 얻은 핵심 인사이트 -- 예측 설명 가능성</a:t>
+            </a:r>
+          </a:p>
+        </p:txBody>
+      </p:sp>
+      <p:pic>
+        <p:nvPicPr>
+          <p:cNvPr id="3" name="Picture 2" descr="image.png"/>
+          <p:cNvPicPr>
+            <a:picLocks noChangeAspect="1"/>
+          </p:cNvPicPr>
+          <p:nvPr/>
+        </p:nvPicPr>
+        <p:blipFill>
+          <a:blip r:embed="rId2"/>
+          <a:stretch>
+            <a:fillRect/>
+          </a:stretch>
+        </p:blipFill>
+        <p:spPr>
+          <a:xfrm>
+            <a:off x="182880" y="640080"/>
+            <a:ext cx="5303520" cy="1988820"/>
+          </a:xfrm>
+          <a:prstGeom prst="rect">
+            <a:avLst/>
+          </a:prstGeom>
+        </p:spPr>
+      </p:pic>
+      <p:sp>
+        <p:nvSpPr>
+          <p:cNvPr id="4" name="TextBox 3"/>
+          <p:cNvSpPr txBox="1"/>
+          <p:nvPr/>
+        </p:nvSpPr>
+        <p:spPr>
+          <a:xfrm>
+            <a:off x="5669280" y="640080"/>
+            <a:ext cx="3200400" cy="365760"/>
+          </a:xfrm>
+          <a:prstGeom prst="rect">
+            <a:avLst/>
+          </a:prstGeom>
+          <a:noFill/>
+        </p:spPr>
+        <p:txBody>
+          <a:bodyPr wrap="square">
+            <a:spAutoFit/>
+          </a:bodyPr>
+          <a:lstStyle/>
+          <a:p>
+            <a:pPr algn="l"/>
+            <a:r>
+              <a:rPr sz="1200" b="1">
+                <a:solidFill>
+                  <a:srgbClr val="2E75B6"/>
+                </a:solidFill>
+              </a:rPr>
+              <a:t>핵심 인사이트</a:t>
+            </a:r>
+          </a:p>
+        </p:txBody>
+      </p:sp>
+      <p:sp>
+        <p:nvSpPr>
+          <p:cNvPr id="5" name="TextBox 4"/>
+          <p:cNvSpPr txBox="1"/>
+          <p:nvPr/>
+        </p:nvSpPr>
+        <p:spPr>
+          <a:xfrm>
+            <a:off x="5669280" y="1051560"/>
+            <a:ext cx="3291840" cy="3840480"/>
+          </a:xfrm>
+          <a:prstGeom prst="rect">
+            <a:avLst/>
+          </a:prstGeom>
+          <a:noFill/>
+        </p:spPr>
+        <p:txBody>
+          <a:bodyPr wrap="square">
+            <a:spAutoFit/>
+          </a:bodyPr>
+          <a:lstStyle/>
+          <a:p>
+            <a:pPr algn="l"/>
+            <a:r>
+              <a:rPr sz="1000" b="0">
+                <a:solidFill>
+                  <a:srgbClr val="1A1A1A"/>
+                </a:solidFill>
+              </a:rPr>
+              <a:t>1. 어느 신호가 중요한가?
+   h_rms(수평 진동 RMS)가 두 모델 공통 1위
+   -&gt; 열화 초기부터 진폭 변화가 가장 큰 지표
+2. 두 모델 비교
+   ML(분류): 특징 위계가 뚜렷 (RMS &gt; 첨도 &gt; 왜도)
+   DL(RUL): 시간축 평균화로 전반적 패턴 반영
+3. 포트폴리오 차별점
+   '블랙박스' DL에 SHAP 적용 -&gt; 신뢰 가능한
+   예지보전 시스템으로 발전</a:t>
+            </a:r>
+          </a:p>
+        </p:txBody>
+      </p:sp>
+      <p:sp>
+        <p:nvSpPr>
+          <p:cNvPr id="6" name="TextBox 5"/>
+          <p:cNvSpPr txBox="1"/>
+          <p:nvPr/>
+        </p:nvSpPr>
+        <p:spPr>
+          <a:xfrm>
+            <a:off x="274320" y="5577840"/>
+            <a:ext cx="11640312" cy="777240"/>
+          </a:xfrm>
+          <a:prstGeom prst="rect">
+            <a:avLst/>
+          </a:prstGeom>
+          <a:noFill/>
+        </p:spPr>
+        <p:txBody>
+          <a:bodyPr wrap="square">
+            <a:spAutoFit/>
+          </a:bodyPr>
+          <a:lstStyle/>
+          <a:p>
+            <a:pPr algn="l"/>
+            <a:r>
+              <a:rPr sz="950" b="0">
+                <a:solidFill>
+                  <a:srgbClr val="C00000"/>
+                </a:solidFill>
+              </a:rPr>
+              <a:t>* DL(GRU) SHAP: 시간 축 평균화 근사 (KernelExplainer) 사용 -- 계산 비용(CPU 1분+)으로 실시간 설명은 제한적. ML 모델은 LinearExplainer로 정확한 SHAP 산출.</a:t>
             </a:r>
           </a:p>
         </p:txBody>

</xml_diff>